<commit_message>
Sync alla sessioner: ilmonte full run + moonshots + multi-session-rutin i CLAUDE.md
- Ilmonte: 28 artiklar live, Rank Math metadata på alla 25 posts, H1 fixad,
  robots.txt uppdaterad, 15 interna länkblock, Peter-mail draft i Gmail
- CLAUDE.md: multi-session-rutin + komplett moonshot-lista (17 mål)
- memory/CLAUDE_GLOBAL.md: global Claude-config för ny Mac
- Nya artiklar: tobler, traficator, nordicsnus, ilmonte vecka 21-23
- Presentationer: tobler-pitch, traficator-möte, möbelrondellen-audit

Co-Authored-By: Claude Sonnet 4.6 <noreply@anthropic.com>
</commit_message>
<xml_diff>
--- a/presentations/output/traficator-omsignering-2026-04-10.pptx
+++ b/presentations/output/traficator-omsignering-2026-04-10.pptx
@@ -17,6 +17,8 @@
     <p:sldId id="265" r:id="rId16"/>
     <p:sldId id="266" r:id="rId17"/>
     <p:sldId id="267" r:id="rId18"/>
+    <p:sldId id="270" r:id="rId21"/>
+    <p:sldId id="271" r:id="rId22"/>
     <p:sldId id="268" r:id="rId19"/>
     <p:sldId id="269" r:id="rId20"/>
   </p:sldIdLst>
@@ -6732,6 +6734,3328 @@
           <a:lstStyle/>
           <a:p>
             <a:pPr algn="ctr"/>
+          </a:p>
+        </p:txBody>
+      </p:sp>
+    </p:spTree>
+  </p:cSld>
+  <p:clrMapOvr>
+    <a:masterClrMapping/>
+  </p:clrMapOvr>
+</p:sld>
+</file>
+
+<file path=ppt/slides/slide15.xml><?xml version="1.0" encoding="utf-8"?>
+<p:sld xmlns:a="http://schemas.openxmlformats.org/drawingml/2006/main" xmlns:p="http://schemas.openxmlformats.org/presentationml/2006/main" xmlns:r="http://schemas.openxmlformats.org/officeDocument/2006/relationships">
+  <p:cSld>
+    <p:bg>
+      <p:bgPr>
+        <a:solidFill>
+          <a:srgbClr val="FFFFFF"/>
+        </a:solidFill>
+        <a:effectLst/>
+      </p:bgPr>
+    </p:bg>
+    <p:spTree>
+      <p:nvGrpSpPr>
+        <p:cNvPr id="1" name=""/>
+        <p:cNvGrpSpPr/>
+        <p:nvPr/>
+      </p:nvGrpSpPr>
+      <p:grpSpPr/>
+      <p:sp>
+        <p:nvSpPr>
+          <p:cNvPr id="2" name="Rectangle 1"/>
+          <p:cNvSpPr/>
+          <p:nvPr/>
+        </p:nvSpPr>
+        <p:spPr>
+          <a:xfrm>
+            <a:off x="0" y="0"/>
+            <a:ext cx="9144000" cy="73152"/>
+          </a:xfrm>
+          <a:prstGeom prst="rect">
+            <a:avLst/>
+          </a:prstGeom>
+          <a:solidFill>
+            <a:srgbClr val="DD3333"/>
+          </a:solidFill>
+          <a:ln>
+            <a:noFill/>
+          </a:ln>
+        </p:spPr>
+        <p:style>
+          <a:lnRef idx="1">
+            <a:schemeClr val="accent1"/>
+          </a:lnRef>
+          <a:fillRef idx="3">
+            <a:schemeClr val="accent1"/>
+          </a:fillRef>
+          <a:effectRef idx="2">
+            <a:schemeClr val="accent1"/>
+          </a:effectRef>
+          <a:fontRef idx="minor">
+            <a:schemeClr val="lt1"/>
+          </a:fontRef>
+        </p:style>
+        <p:txBody>
+          <a:bodyPr rtlCol="0" anchor="ctr"/>
+          <a:lstStyle/>
+          <a:p>
+            <a:pPr algn="ctr"/>
+          </a:p>
+        </p:txBody>
+      </p:sp>
+      <p:sp>
+        <p:nvSpPr>
+          <p:cNvPr id="3" name="TextBox 2"/>
+          <p:cNvSpPr txBox="1"/>
+          <p:nvPr/>
+        </p:nvSpPr>
+        <p:spPr>
+          <a:xfrm>
+            <a:off x="457200" y="274320"/>
+            <a:ext cx="2743200" cy="274320"/>
+          </a:xfrm>
+          <a:prstGeom prst="rect">
+            <a:avLst/>
+          </a:prstGeom>
+          <a:noFill/>
+        </p:spPr>
+        <p:txBody>
+          <a:bodyPr wrap="square">
+            <a:spAutoFit/>
+          </a:bodyPr>
+          <a:lstStyle/>
+          <a:p>
+            <a:pPr algn="l">
+              <a:defRPr sz="1100" b="1">
+                <a:solidFill>
+                  <a:srgbClr val="DD3333"/>
+                </a:solidFill>
+                <a:latin typeface="Calibri"/>
+              </a:defRPr>
+            </a:pPr>
+            <a:r>
+              <a:t>EXPANSION</a:t>
+            </a:r>
+          </a:p>
+        </p:txBody>
+      </p:sp>
+      <p:sp>
+        <p:nvSpPr>
+          <p:cNvPr id="4" name="TextBox 3"/>
+          <p:cNvSpPr txBox="1"/>
+          <p:nvPr/>
+        </p:nvSpPr>
+        <p:spPr>
+          <a:xfrm>
+            <a:off x="457200" y="548640"/>
+            <a:ext cx="7315200" cy="457200"/>
+          </a:xfrm>
+          <a:prstGeom prst="rect">
+            <a:avLst/>
+          </a:prstGeom>
+          <a:noFill/>
+        </p:spPr>
+        <p:txBody>
+          <a:bodyPr wrap="square">
+            <a:spAutoFit/>
+          </a:bodyPr>
+          <a:lstStyle/>
+          <a:p>
+            <a:pPr algn="l">
+              <a:defRPr sz="2800" b="1">
+                <a:solidFill>
+                  <a:srgbClr val="1A1A1A"/>
+                </a:solidFill>
+                <a:latin typeface="Calibri"/>
+              </a:defRPr>
+            </a:pPr>
+            <a:r>
+              <a:t>Utöver artiklar — 20+ nya landningssidor</a:t>
+            </a:r>
+          </a:p>
+        </p:txBody>
+      </p:sp>
+      <p:sp>
+        <p:nvSpPr>
+          <p:cNvPr id="5" name="TextBox 4"/>
+          <p:cNvSpPr txBox="1"/>
+          <p:nvPr/>
+        </p:nvSpPr>
+        <p:spPr>
+          <a:xfrm>
+            <a:off x="457200" y="1051560"/>
+            <a:ext cx="7315200" cy="365760"/>
+          </a:xfrm>
+          <a:prstGeom prst="rect">
+            <a:avLst/>
+          </a:prstGeom>
+          <a:noFill/>
+        </p:spPr>
+        <p:txBody>
+          <a:bodyPr wrap="square">
+            <a:spAutoFit/>
+          </a:bodyPr>
+          <a:lstStyle/>
+          <a:p>
+            <a:pPr algn="l">
+              <a:defRPr sz="1300" b="0">
+                <a:solidFill>
+                  <a:srgbClr val="999999"/>
+                </a:solidFill>
+                <a:latin typeface="Calibri"/>
+              </a:defRPr>
+            </a:pPr>
+            <a:r>
+              <a:t>Permanenta sidor som bygger Traficator till den självklara resursen för gjutning i Sverige</a:t>
+            </a:r>
+          </a:p>
+        </p:txBody>
+      </p:sp>
+      <p:sp>
+        <p:nvSpPr>
+          <p:cNvPr id="6" name="Rectangle 5"/>
+          <p:cNvSpPr/>
+          <p:nvPr/>
+        </p:nvSpPr>
+        <p:spPr>
+          <a:xfrm>
+            <a:off x="457200" y="1554480"/>
+            <a:ext cx="2651760" cy="1920240"/>
+          </a:xfrm>
+          <a:prstGeom prst="rect">
+            <a:avLst/>
+          </a:prstGeom>
+          <a:solidFill>
+            <a:srgbClr val="F5F5F5"/>
+          </a:solidFill>
+          <a:ln>
+            <a:noFill/>
+          </a:ln>
+        </p:spPr>
+        <p:style>
+          <a:lnRef idx="1">
+            <a:schemeClr val="accent1"/>
+          </a:lnRef>
+          <a:fillRef idx="3">
+            <a:schemeClr val="accent1"/>
+          </a:fillRef>
+          <a:effectRef idx="2">
+            <a:schemeClr val="accent1"/>
+          </a:effectRef>
+          <a:fontRef idx="minor">
+            <a:schemeClr val="lt1"/>
+          </a:fontRef>
+        </p:style>
+        <p:txBody>
+          <a:bodyPr rtlCol="0" anchor="ctr"/>
+          <a:lstStyle/>
+          <a:p>
+            <a:pPr algn="ctr"/>
+          </a:p>
+        </p:txBody>
+      </p:sp>
+      <p:sp>
+        <p:nvSpPr>
+          <p:cNvPr id="7" name="TextBox 6"/>
+          <p:cNvSpPr txBox="1"/>
+          <p:nvPr/>
+        </p:nvSpPr>
+        <p:spPr>
+          <a:xfrm>
+            <a:off x="594360" y="1645920"/>
+            <a:ext cx="2377440" cy="274320"/>
+          </a:xfrm>
+          <a:prstGeom prst="rect">
+            <a:avLst/>
+          </a:prstGeom>
+          <a:noFill/>
+        </p:spPr>
+        <p:txBody>
+          <a:bodyPr wrap="square">
+            <a:spAutoFit/>
+          </a:bodyPr>
+          <a:lstStyle/>
+          <a:p>
+            <a:pPr algn="l">
+              <a:defRPr sz="1300" b="1">
+                <a:solidFill>
+                  <a:srgbClr val="1A1A1A"/>
+                </a:solidFill>
+                <a:latin typeface="Calibri"/>
+              </a:defRPr>
+            </a:pPr>
+            <a:r>
+              <a:t>Branschsidor</a:t>
+            </a:r>
+          </a:p>
+        </p:txBody>
+      </p:sp>
+      <p:sp>
+        <p:nvSpPr>
+          <p:cNvPr id="8" name="TextBox 7"/>
+          <p:cNvSpPr txBox="1"/>
+          <p:nvPr/>
+        </p:nvSpPr>
+        <p:spPr>
+          <a:xfrm>
+            <a:off x="594360" y="1920240"/>
+            <a:ext cx="1097280" cy="228600"/>
+          </a:xfrm>
+          <a:prstGeom prst="rect">
+            <a:avLst/>
+          </a:prstGeom>
+          <a:noFill/>
+        </p:spPr>
+        <p:txBody>
+          <a:bodyPr wrap="square">
+            <a:spAutoFit/>
+          </a:bodyPr>
+          <a:lstStyle/>
+          <a:p>
+            <a:pPr algn="l">
+              <a:defRPr sz="1100" b="1">
+                <a:solidFill>
+                  <a:srgbClr val="DD3333"/>
+                </a:solidFill>
+                <a:latin typeface="Calibri"/>
+              </a:defRPr>
+            </a:pPr>
+            <a:r>
+              <a:t>5 sidor</a:t>
+            </a:r>
+          </a:p>
+        </p:txBody>
+      </p:sp>
+      <p:sp>
+        <p:nvSpPr>
+          <p:cNvPr id="9" name="TextBox 8"/>
+          <p:cNvSpPr txBox="1"/>
+          <p:nvPr/>
+        </p:nvSpPr>
+        <p:spPr>
+          <a:xfrm>
+            <a:off x="594360" y="2194560"/>
+            <a:ext cx="2377440" cy="640080"/>
+          </a:xfrm>
+          <a:prstGeom prst="rect">
+            <a:avLst/>
+          </a:prstGeom>
+          <a:noFill/>
+        </p:spPr>
+        <p:txBody>
+          <a:bodyPr wrap="square">
+            <a:spAutoFit/>
+          </a:bodyPr>
+          <a:lstStyle/>
+          <a:p>
+            <a:pPr algn="l">
+              <a:defRPr sz="1000" b="0">
+                <a:solidFill>
+                  <a:srgbClr val="999999"/>
+                </a:solidFill>
+                <a:latin typeface="Calibri"/>
+              </a:defRPr>
+            </a:pPr>
+            <a:r>
+              <a:t>Fordon • Marin • Energi</a:t>
+            </a:r>
+            <a:br/>
+            <a:r>
+              <a:t>Bygg • Medicinteknik</a:t>
+            </a:r>
+          </a:p>
+        </p:txBody>
+      </p:sp>
+      <p:sp>
+        <p:nvSpPr>
+          <p:cNvPr id="10" name="TextBox 9"/>
+          <p:cNvSpPr txBox="1"/>
+          <p:nvPr/>
+        </p:nvSpPr>
+        <p:spPr>
+          <a:xfrm>
+            <a:off x="594360" y="2926080"/>
+            <a:ext cx="2377440" cy="457200"/>
+          </a:xfrm>
+          <a:prstGeom prst="rect">
+            <a:avLst/>
+          </a:prstGeom>
+          <a:noFill/>
+        </p:spPr>
+        <p:txBody>
+          <a:bodyPr wrap="square">
+            <a:spAutoFit/>
+          </a:bodyPr>
+          <a:lstStyle/>
+          <a:p>
+            <a:pPr algn="l">
+              <a:defRPr sz="1000" b="0">
+                <a:solidFill>
+                  <a:srgbClr val="1A1A1A"/>
+                </a:solidFill>
+                <a:latin typeface="Calibri"/>
+              </a:defRPr>
+            </a:pPr>
+            <a:r>
+              <a:t>Eget sökords-kluster</a:t>
+            </a:r>
+            <a:br/>
+            <a:r>
+              <a:t>per bransch</a:t>
+            </a:r>
+          </a:p>
+        </p:txBody>
+      </p:sp>
+      <p:sp>
+        <p:nvSpPr>
+          <p:cNvPr id="11" name="Rectangle 10"/>
+          <p:cNvSpPr/>
+          <p:nvPr/>
+        </p:nvSpPr>
+        <p:spPr>
+          <a:xfrm>
+            <a:off x="3291840" y="1554480"/>
+            <a:ext cx="2651760" cy="1920240"/>
+          </a:xfrm>
+          <a:prstGeom prst="rect">
+            <a:avLst/>
+          </a:prstGeom>
+          <a:solidFill>
+            <a:srgbClr val="F5F5F5"/>
+          </a:solidFill>
+          <a:ln>
+            <a:noFill/>
+          </a:ln>
+        </p:spPr>
+        <p:style>
+          <a:lnRef idx="1">
+            <a:schemeClr val="accent1"/>
+          </a:lnRef>
+          <a:fillRef idx="3">
+            <a:schemeClr val="accent1"/>
+          </a:fillRef>
+          <a:effectRef idx="2">
+            <a:schemeClr val="accent1"/>
+          </a:effectRef>
+          <a:fontRef idx="minor">
+            <a:schemeClr val="lt1"/>
+          </a:fontRef>
+        </p:style>
+        <p:txBody>
+          <a:bodyPr rtlCol="0" anchor="ctr"/>
+          <a:lstStyle/>
+          <a:p>
+            <a:pPr algn="ctr"/>
+          </a:p>
+        </p:txBody>
+      </p:sp>
+      <p:sp>
+        <p:nvSpPr>
+          <p:cNvPr id="12" name="TextBox 11"/>
+          <p:cNvSpPr txBox="1"/>
+          <p:nvPr/>
+        </p:nvSpPr>
+        <p:spPr>
+          <a:xfrm>
+            <a:off x="3429000" y="1645920"/>
+            <a:ext cx="2377440" cy="274320"/>
+          </a:xfrm>
+          <a:prstGeom prst="rect">
+            <a:avLst/>
+          </a:prstGeom>
+          <a:noFill/>
+        </p:spPr>
+        <p:txBody>
+          <a:bodyPr wrap="square">
+            <a:spAutoFit/>
+          </a:bodyPr>
+          <a:lstStyle/>
+          <a:p>
+            <a:pPr algn="l">
+              <a:defRPr sz="1300" b="1">
+                <a:solidFill>
+                  <a:srgbClr val="1A1A1A"/>
+                </a:solidFill>
+                <a:latin typeface="Calibri"/>
+              </a:defRPr>
+            </a:pPr>
+            <a:r>
+              <a:t>Materialsidor</a:t>
+            </a:r>
+          </a:p>
+        </p:txBody>
+      </p:sp>
+      <p:sp>
+        <p:nvSpPr>
+          <p:cNvPr id="13" name="TextBox 12"/>
+          <p:cNvSpPr txBox="1"/>
+          <p:nvPr/>
+        </p:nvSpPr>
+        <p:spPr>
+          <a:xfrm>
+            <a:off x="3429000" y="1920240"/>
+            <a:ext cx="1097280" cy="228600"/>
+          </a:xfrm>
+          <a:prstGeom prst="rect">
+            <a:avLst/>
+          </a:prstGeom>
+          <a:noFill/>
+        </p:spPr>
+        <p:txBody>
+          <a:bodyPr wrap="square">
+            <a:spAutoFit/>
+          </a:bodyPr>
+          <a:lstStyle/>
+          <a:p>
+            <a:pPr algn="l">
+              <a:defRPr sz="1100" b="1">
+                <a:solidFill>
+                  <a:srgbClr val="DD3333"/>
+                </a:solidFill>
+                <a:latin typeface="Calibri"/>
+              </a:defRPr>
+            </a:pPr>
+            <a:r>
+              <a:t>4 sidor</a:t>
+            </a:r>
+          </a:p>
+        </p:txBody>
+      </p:sp>
+      <p:sp>
+        <p:nvSpPr>
+          <p:cNvPr id="14" name="TextBox 13"/>
+          <p:cNvSpPr txBox="1"/>
+          <p:nvPr/>
+        </p:nvSpPr>
+        <p:spPr>
+          <a:xfrm>
+            <a:off x="3429000" y="2194560"/>
+            <a:ext cx="2377440" cy="640080"/>
+          </a:xfrm>
+          <a:prstGeom prst="rect">
+            <a:avLst/>
+          </a:prstGeom>
+          <a:noFill/>
+        </p:spPr>
+        <p:txBody>
+          <a:bodyPr wrap="square">
+            <a:spAutoFit/>
+          </a:bodyPr>
+          <a:lstStyle/>
+          <a:p>
+            <a:pPr algn="l">
+              <a:defRPr sz="1000" b="0">
+                <a:solidFill>
+                  <a:srgbClr val="999999"/>
+                </a:solidFill>
+                <a:latin typeface="Calibri"/>
+              </a:defRPr>
+            </a:pPr>
+            <a:r>
+              <a:t>Koppar/mässing • Rostfritt</a:t>
+            </a:r>
+            <a:br/>
+            <a:r>
+              <a:t>Zink • Gjutjärn</a:t>
+            </a:r>
+          </a:p>
+        </p:txBody>
+      </p:sp>
+      <p:sp>
+        <p:nvSpPr>
+          <p:cNvPr id="15" name="TextBox 14"/>
+          <p:cNvSpPr txBox="1"/>
+          <p:nvPr/>
+        </p:nvSpPr>
+        <p:spPr>
+          <a:xfrm>
+            <a:off x="3429000" y="2926080"/>
+            <a:ext cx="2377440" cy="457200"/>
+          </a:xfrm>
+          <a:prstGeom prst="rect">
+            <a:avLst/>
+          </a:prstGeom>
+          <a:noFill/>
+        </p:spPr>
+        <p:txBody>
+          <a:bodyPr wrap="square">
+            <a:spAutoFit/>
+          </a:bodyPr>
+          <a:lstStyle/>
+          <a:p>
+            <a:pPr algn="l">
+              <a:defRPr sz="1000" b="0">
+                <a:solidFill>
+                  <a:srgbClr val="1A1A1A"/>
+                </a:solidFill>
+                <a:latin typeface="Calibri"/>
+              </a:defRPr>
+            </a:pPr>
+            <a:r>
+              <a:t>Rankar på</a:t>
+            </a:r>
+            <a:br/>
+            <a:r>
+              <a:t>materialsökningar</a:t>
+            </a:r>
+          </a:p>
+        </p:txBody>
+      </p:sp>
+      <p:sp>
+        <p:nvSpPr>
+          <p:cNvPr id="16" name="Rectangle 15"/>
+          <p:cNvSpPr/>
+          <p:nvPr/>
+        </p:nvSpPr>
+        <p:spPr>
+          <a:xfrm>
+            <a:off x="6126480" y="1554480"/>
+            <a:ext cx="2651760" cy="1920240"/>
+          </a:xfrm>
+          <a:prstGeom prst="rect">
+            <a:avLst/>
+          </a:prstGeom>
+          <a:solidFill>
+            <a:srgbClr val="F5F5F5"/>
+          </a:solidFill>
+          <a:ln>
+            <a:noFill/>
+          </a:ln>
+        </p:spPr>
+        <p:style>
+          <a:lnRef idx="1">
+            <a:schemeClr val="accent1"/>
+          </a:lnRef>
+          <a:fillRef idx="3">
+            <a:schemeClr val="accent1"/>
+          </a:fillRef>
+          <a:effectRef idx="2">
+            <a:schemeClr val="accent1"/>
+          </a:effectRef>
+          <a:fontRef idx="minor">
+            <a:schemeClr val="lt1"/>
+          </a:fontRef>
+        </p:style>
+        <p:txBody>
+          <a:bodyPr rtlCol="0" anchor="ctr"/>
+          <a:lstStyle/>
+          <a:p>
+            <a:pPr algn="ctr"/>
+          </a:p>
+        </p:txBody>
+      </p:sp>
+      <p:sp>
+        <p:nvSpPr>
+          <p:cNvPr id="17" name="TextBox 16"/>
+          <p:cNvSpPr txBox="1"/>
+          <p:nvPr/>
+        </p:nvSpPr>
+        <p:spPr>
+          <a:xfrm>
+            <a:off x="6263640" y="1645920"/>
+            <a:ext cx="2377440" cy="274320"/>
+          </a:xfrm>
+          <a:prstGeom prst="rect">
+            <a:avLst/>
+          </a:prstGeom>
+          <a:noFill/>
+        </p:spPr>
+        <p:txBody>
+          <a:bodyPr wrap="square">
+            <a:spAutoFit/>
+          </a:bodyPr>
+          <a:lstStyle/>
+          <a:p>
+            <a:pPr algn="l">
+              <a:defRPr sz="1300" b="1">
+                <a:solidFill>
+                  <a:srgbClr val="1A1A1A"/>
+                </a:solidFill>
+                <a:latin typeface="Calibri"/>
+              </a:defRPr>
+            </a:pPr>
+            <a:r>
+              <a:t>Jämförelsesidor</a:t>
+            </a:r>
+          </a:p>
+        </p:txBody>
+      </p:sp>
+      <p:sp>
+        <p:nvSpPr>
+          <p:cNvPr id="18" name="TextBox 17"/>
+          <p:cNvSpPr txBox="1"/>
+          <p:nvPr/>
+        </p:nvSpPr>
+        <p:spPr>
+          <a:xfrm>
+            <a:off x="6263640" y="1920240"/>
+            <a:ext cx="1097280" cy="228600"/>
+          </a:xfrm>
+          <a:prstGeom prst="rect">
+            <a:avLst/>
+          </a:prstGeom>
+          <a:noFill/>
+        </p:spPr>
+        <p:txBody>
+          <a:bodyPr wrap="square">
+            <a:spAutoFit/>
+          </a:bodyPr>
+          <a:lstStyle/>
+          <a:p>
+            <a:pPr algn="l">
+              <a:defRPr sz="1100" b="1">
+                <a:solidFill>
+                  <a:srgbClr val="DD3333"/>
+                </a:solidFill>
+                <a:latin typeface="Calibri"/>
+              </a:defRPr>
+            </a:pPr>
+            <a:r>
+              <a:t>4 sidor</a:t>
+            </a:r>
+          </a:p>
+        </p:txBody>
+      </p:sp>
+      <p:sp>
+        <p:nvSpPr>
+          <p:cNvPr id="19" name="TextBox 18"/>
+          <p:cNvSpPr txBox="1"/>
+          <p:nvPr/>
+        </p:nvSpPr>
+        <p:spPr>
+          <a:xfrm>
+            <a:off x="6263640" y="2194560"/>
+            <a:ext cx="2377440" cy="640080"/>
+          </a:xfrm>
+          <a:prstGeom prst="rect">
+            <a:avLst/>
+          </a:prstGeom>
+          <a:noFill/>
+        </p:spPr>
+        <p:txBody>
+          <a:bodyPr wrap="square">
+            <a:spAutoFit/>
+          </a:bodyPr>
+          <a:lstStyle/>
+          <a:p>
+            <a:pPr algn="l">
+              <a:defRPr sz="1000" b="0">
+                <a:solidFill>
+                  <a:srgbClr val="999999"/>
+                </a:solidFill>
+                <a:latin typeface="Calibri"/>
+              </a:defRPr>
+            </a:pPr>
+            <a:r>
+              <a:t>Sand vs Press • CNC vs Gjutning</a:t>
+            </a:r>
+            <a:br/>
+            <a:r>
+              <a:t>3D-print vs Gjutning • SE vs Kina</a:t>
+            </a:r>
+          </a:p>
+        </p:txBody>
+      </p:sp>
+      <p:sp>
+        <p:nvSpPr>
+          <p:cNvPr id="20" name="TextBox 19"/>
+          <p:cNvSpPr txBox="1"/>
+          <p:nvPr/>
+        </p:nvSpPr>
+        <p:spPr>
+          <a:xfrm>
+            <a:off x="6263640" y="2926080"/>
+            <a:ext cx="2377440" cy="457200"/>
+          </a:xfrm>
+          <a:prstGeom prst="rect">
+            <a:avLst/>
+          </a:prstGeom>
+          <a:noFill/>
+        </p:spPr>
+        <p:txBody>
+          <a:bodyPr wrap="square">
+            <a:spAutoFit/>
+          </a:bodyPr>
+          <a:lstStyle/>
+          <a:p>
+            <a:pPr algn="l">
+              <a:defRPr sz="1000" b="0">
+                <a:solidFill>
+                  <a:srgbClr val="1A1A1A"/>
+                </a:solidFill>
+                <a:latin typeface="Calibri"/>
+              </a:defRPr>
+            </a:pPr>
+            <a:r>
+              <a:t>Decision-stage trafik</a:t>
+            </a:r>
+            <a:br/>
+            <a:r>
+              <a:t>hög konvertering</a:t>
+            </a:r>
+          </a:p>
+        </p:txBody>
+      </p:sp>
+      <p:sp>
+        <p:nvSpPr>
+          <p:cNvPr id="21" name="Rectangle 20"/>
+          <p:cNvSpPr/>
+          <p:nvPr/>
+        </p:nvSpPr>
+        <p:spPr>
+          <a:xfrm>
+            <a:off x="457200" y="3657600"/>
+            <a:ext cx="2651760" cy="1920240"/>
+          </a:xfrm>
+          <a:prstGeom prst="rect">
+            <a:avLst/>
+          </a:prstGeom>
+          <a:solidFill>
+            <a:srgbClr val="F5F5F5"/>
+          </a:solidFill>
+          <a:ln>
+            <a:noFill/>
+          </a:ln>
+        </p:spPr>
+        <p:style>
+          <a:lnRef idx="1">
+            <a:schemeClr val="accent1"/>
+          </a:lnRef>
+          <a:fillRef idx="3">
+            <a:schemeClr val="accent1"/>
+          </a:fillRef>
+          <a:effectRef idx="2">
+            <a:schemeClr val="accent1"/>
+          </a:effectRef>
+          <a:fontRef idx="minor">
+            <a:schemeClr val="lt1"/>
+          </a:fontRef>
+        </p:style>
+        <p:txBody>
+          <a:bodyPr rtlCol="0" anchor="ctr"/>
+          <a:lstStyle/>
+          <a:p>
+            <a:pPr algn="ctr"/>
+          </a:p>
+        </p:txBody>
+      </p:sp>
+      <p:sp>
+        <p:nvSpPr>
+          <p:cNvPr id="22" name="TextBox 21"/>
+          <p:cNvSpPr txBox="1"/>
+          <p:nvPr/>
+        </p:nvSpPr>
+        <p:spPr>
+          <a:xfrm>
+            <a:off x="594360" y="3749039"/>
+            <a:ext cx="2377440" cy="274320"/>
+          </a:xfrm>
+          <a:prstGeom prst="rect">
+            <a:avLst/>
+          </a:prstGeom>
+          <a:noFill/>
+        </p:spPr>
+        <p:txBody>
+          <a:bodyPr wrap="square">
+            <a:spAutoFit/>
+          </a:bodyPr>
+          <a:lstStyle/>
+          <a:p>
+            <a:pPr algn="l">
+              <a:defRPr sz="1300" b="1">
+                <a:solidFill>
+                  <a:srgbClr val="1A1A1A"/>
+                </a:solidFill>
+                <a:latin typeface="Calibri"/>
+              </a:defRPr>
+            </a:pPr>
+            <a:r>
+              <a:t>Resurssidor</a:t>
+            </a:r>
+          </a:p>
+        </p:txBody>
+      </p:sp>
+      <p:sp>
+        <p:nvSpPr>
+          <p:cNvPr id="23" name="TextBox 22"/>
+          <p:cNvSpPr txBox="1"/>
+          <p:nvPr/>
+        </p:nvSpPr>
+        <p:spPr>
+          <a:xfrm>
+            <a:off x="594360" y="4023360"/>
+            <a:ext cx="1097280" cy="228600"/>
+          </a:xfrm>
+          <a:prstGeom prst="rect">
+            <a:avLst/>
+          </a:prstGeom>
+          <a:noFill/>
+        </p:spPr>
+        <p:txBody>
+          <a:bodyPr wrap="square">
+            <a:spAutoFit/>
+          </a:bodyPr>
+          <a:lstStyle/>
+          <a:p>
+            <a:pPr algn="l">
+              <a:defRPr sz="1100" b="1">
+                <a:solidFill>
+                  <a:srgbClr val="DD3333"/>
+                </a:solidFill>
+                <a:latin typeface="Calibri"/>
+              </a:defRPr>
+            </a:pPr>
+            <a:r>
+              <a:t>4 sidor</a:t>
+            </a:r>
+          </a:p>
+        </p:txBody>
+      </p:sp>
+      <p:sp>
+        <p:nvSpPr>
+          <p:cNvPr id="24" name="TextBox 23"/>
+          <p:cNvSpPr txBox="1"/>
+          <p:nvPr/>
+        </p:nvSpPr>
+        <p:spPr>
+          <a:xfrm>
+            <a:off x="594360" y="4297680"/>
+            <a:ext cx="2377440" cy="640080"/>
+          </a:xfrm>
+          <a:prstGeom prst="rect">
+            <a:avLst/>
+          </a:prstGeom>
+          <a:noFill/>
+        </p:spPr>
+        <p:txBody>
+          <a:bodyPr wrap="square">
+            <a:spAutoFit/>
+          </a:bodyPr>
+          <a:lstStyle/>
+          <a:p>
+            <a:pPr algn="l">
+              <a:defRPr sz="1000" b="0">
+                <a:solidFill>
+                  <a:srgbClr val="999999"/>
+                </a:solidFill>
+                <a:latin typeface="Calibri"/>
+              </a:defRPr>
+            </a:pPr>
+            <a:r>
+              <a:t>Materialguiden • Offertformulär</a:t>
+            </a:r>
+            <a:br/>
+            <a:r>
+              <a:t>Referensprojekt • Ordlista</a:t>
+            </a:r>
+          </a:p>
+        </p:txBody>
+      </p:sp>
+      <p:sp>
+        <p:nvSpPr>
+          <p:cNvPr id="25" name="TextBox 24"/>
+          <p:cNvSpPr txBox="1"/>
+          <p:nvPr/>
+        </p:nvSpPr>
+        <p:spPr>
+          <a:xfrm>
+            <a:off x="594360" y="5029200"/>
+            <a:ext cx="2377440" cy="457200"/>
+          </a:xfrm>
+          <a:prstGeom prst="rect">
+            <a:avLst/>
+          </a:prstGeom>
+          <a:noFill/>
+        </p:spPr>
+        <p:txBody>
+          <a:bodyPr wrap="square">
+            <a:spAutoFit/>
+          </a:bodyPr>
+          <a:lstStyle/>
+          <a:p>
+            <a:pPr algn="l">
+              <a:defRPr sz="1000" b="0">
+                <a:solidFill>
+                  <a:srgbClr val="1A1A1A"/>
+                </a:solidFill>
+                <a:latin typeface="Calibri"/>
+              </a:defRPr>
+            </a:pPr>
+            <a:r>
+              <a:t>Lead magnets +</a:t>
+            </a:r>
+            <a:br/>
+            <a:r>
+              <a:t>SEO-auktoritet</a:t>
+            </a:r>
+          </a:p>
+        </p:txBody>
+      </p:sp>
+      <p:sp>
+        <p:nvSpPr>
+          <p:cNvPr id="26" name="Rectangle 25"/>
+          <p:cNvSpPr/>
+          <p:nvPr/>
+        </p:nvSpPr>
+        <p:spPr>
+          <a:xfrm>
+            <a:off x="3291840" y="3657600"/>
+            <a:ext cx="2651760" cy="1920240"/>
+          </a:xfrm>
+          <a:prstGeom prst="rect">
+            <a:avLst/>
+          </a:prstGeom>
+          <a:solidFill>
+            <a:srgbClr val="F5F5F5"/>
+          </a:solidFill>
+          <a:ln>
+            <a:noFill/>
+          </a:ln>
+        </p:spPr>
+        <p:style>
+          <a:lnRef idx="1">
+            <a:schemeClr val="accent1"/>
+          </a:lnRef>
+          <a:fillRef idx="3">
+            <a:schemeClr val="accent1"/>
+          </a:fillRef>
+          <a:effectRef idx="2">
+            <a:schemeClr val="accent1"/>
+          </a:effectRef>
+          <a:fontRef idx="minor">
+            <a:schemeClr val="lt1"/>
+          </a:fontRef>
+        </p:style>
+        <p:txBody>
+          <a:bodyPr rtlCol="0" anchor="ctr"/>
+          <a:lstStyle/>
+          <a:p>
+            <a:pPr algn="ctr"/>
+          </a:p>
+        </p:txBody>
+      </p:sp>
+      <p:sp>
+        <p:nvSpPr>
+          <p:cNvPr id="27" name="TextBox 26"/>
+          <p:cNvSpPr txBox="1"/>
+          <p:nvPr/>
+        </p:nvSpPr>
+        <p:spPr>
+          <a:xfrm>
+            <a:off x="3429000" y="3749039"/>
+            <a:ext cx="2377440" cy="274320"/>
+          </a:xfrm>
+          <a:prstGeom prst="rect">
+            <a:avLst/>
+          </a:prstGeom>
+          <a:noFill/>
+        </p:spPr>
+        <p:txBody>
+          <a:bodyPr wrap="square">
+            <a:spAutoFit/>
+          </a:bodyPr>
+          <a:lstStyle/>
+          <a:p>
+            <a:pPr algn="l">
+              <a:defRPr sz="1300" b="1">
+                <a:solidFill>
+                  <a:srgbClr val="1A1A1A"/>
+                </a:solidFill>
+                <a:latin typeface="Calibri"/>
+              </a:defRPr>
+            </a:pPr>
+            <a:r>
+              <a:t>Geografiska sidor</a:t>
+            </a:r>
+          </a:p>
+        </p:txBody>
+      </p:sp>
+      <p:sp>
+        <p:nvSpPr>
+          <p:cNvPr id="28" name="TextBox 27"/>
+          <p:cNvSpPr txBox="1"/>
+          <p:nvPr/>
+        </p:nvSpPr>
+        <p:spPr>
+          <a:xfrm>
+            <a:off x="3429000" y="4023360"/>
+            <a:ext cx="1097280" cy="228600"/>
+          </a:xfrm>
+          <a:prstGeom prst="rect">
+            <a:avLst/>
+          </a:prstGeom>
+          <a:noFill/>
+        </p:spPr>
+        <p:txBody>
+          <a:bodyPr wrap="square">
+            <a:spAutoFit/>
+          </a:bodyPr>
+          <a:lstStyle/>
+          <a:p>
+            <a:pPr algn="l">
+              <a:defRPr sz="1100" b="1">
+                <a:solidFill>
+                  <a:srgbClr val="DD3333"/>
+                </a:solidFill>
+                <a:latin typeface="Calibri"/>
+              </a:defRPr>
+            </a:pPr>
+            <a:r>
+              <a:t>2 sidor</a:t>
+            </a:r>
+          </a:p>
+        </p:txBody>
+      </p:sp>
+      <p:sp>
+        <p:nvSpPr>
+          <p:cNvPr id="29" name="TextBox 28"/>
+          <p:cNvSpPr txBox="1"/>
+          <p:nvPr/>
+        </p:nvSpPr>
+        <p:spPr>
+          <a:xfrm>
+            <a:off x="3429000" y="4297680"/>
+            <a:ext cx="2377440" cy="640080"/>
+          </a:xfrm>
+          <a:prstGeom prst="rect">
+            <a:avLst/>
+          </a:prstGeom>
+          <a:noFill/>
+        </p:spPr>
+        <p:txBody>
+          <a:bodyPr wrap="square">
+            <a:spAutoFit/>
+          </a:bodyPr>
+          <a:lstStyle/>
+          <a:p>
+            <a:pPr algn="l">
+              <a:defRPr sz="1000" b="0">
+                <a:solidFill>
+                  <a:srgbClr val="999999"/>
+                </a:solidFill>
+                <a:latin typeface="Calibri"/>
+              </a:defRPr>
+            </a:pPr>
+            <a:r>
+              <a:t>Gjuteri Småland</a:t>
+            </a:r>
+            <a:br/>
+            <a:r>
+              <a:t>Gjuteri Sverige</a:t>
+            </a:r>
+          </a:p>
+        </p:txBody>
+      </p:sp>
+      <p:sp>
+        <p:nvSpPr>
+          <p:cNvPr id="30" name="TextBox 29"/>
+          <p:cNvSpPr txBox="1"/>
+          <p:nvPr/>
+        </p:nvSpPr>
+        <p:spPr>
+          <a:xfrm>
+            <a:off x="3429000" y="5029200"/>
+            <a:ext cx="2377440" cy="457200"/>
+          </a:xfrm>
+          <a:prstGeom prst="rect">
+            <a:avLst/>
+          </a:prstGeom>
+          <a:noFill/>
+        </p:spPr>
+        <p:txBody>
+          <a:bodyPr wrap="square">
+            <a:spAutoFit/>
+          </a:bodyPr>
+          <a:lstStyle/>
+          <a:p>
+            <a:pPr algn="l">
+              <a:defRPr sz="1000" b="0">
+                <a:solidFill>
+                  <a:srgbClr val="1A1A1A"/>
+                </a:solidFill>
+                <a:latin typeface="Calibri"/>
+              </a:defRPr>
+            </a:pPr>
+            <a:r>
+              <a:t>Lokala sökningar</a:t>
+            </a:r>
+            <a:br/>
+            <a:r>
+              <a:t>nära köpbeslut</a:t>
+            </a:r>
+          </a:p>
+        </p:txBody>
+      </p:sp>
+      <p:sp>
+        <p:nvSpPr>
+          <p:cNvPr id="31" name="Rectangle 30"/>
+          <p:cNvSpPr/>
+          <p:nvPr/>
+        </p:nvSpPr>
+        <p:spPr>
+          <a:xfrm>
+            <a:off x="6126480" y="3657600"/>
+            <a:ext cx="2651760" cy="1920240"/>
+          </a:xfrm>
+          <a:prstGeom prst="rect">
+            <a:avLst/>
+          </a:prstGeom>
+          <a:solidFill>
+            <a:srgbClr val="F5F5F5"/>
+          </a:solidFill>
+          <a:ln>
+            <a:noFill/>
+          </a:ln>
+        </p:spPr>
+        <p:style>
+          <a:lnRef idx="1">
+            <a:schemeClr val="accent1"/>
+          </a:lnRef>
+          <a:fillRef idx="3">
+            <a:schemeClr val="accent1"/>
+          </a:fillRef>
+          <a:effectRef idx="2">
+            <a:schemeClr val="accent1"/>
+          </a:effectRef>
+          <a:fontRef idx="minor">
+            <a:schemeClr val="lt1"/>
+          </a:fontRef>
+        </p:style>
+        <p:txBody>
+          <a:bodyPr rtlCol="0" anchor="ctr"/>
+          <a:lstStyle/>
+          <a:p>
+            <a:pPr algn="ctr"/>
+          </a:p>
+        </p:txBody>
+      </p:sp>
+      <p:sp>
+        <p:nvSpPr>
+          <p:cNvPr id="32" name="TextBox 31"/>
+          <p:cNvSpPr txBox="1"/>
+          <p:nvPr/>
+        </p:nvSpPr>
+        <p:spPr>
+          <a:xfrm>
+            <a:off x="6263640" y="3749039"/>
+            <a:ext cx="2377440" cy="274320"/>
+          </a:xfrm>
+          <a:prstGeom prst="rect">
+            <a:avLst/>
+          </a:prstGeom>
+          <a:noFill/>
+        </p:spPr>
+        <p:txBody>
+          <a:bodyPr wrap="square">
+            <a:spAutoFit/>
+          </a:bodyPr>
+          <a:lstStyle/>
+          <a:p>
+            <a:pPr algn="l">
+              <a:defRPr sz="1300" b="1">
+                <a:solidFill>
+                  <a:srgbClr val="1A1A1A"/>
+                </a:solidFill>
+                <a:latin typeface="Calibri"/>
+              </a:defRPr>
+            </a:pPr>
+            <a:r>
+              <a:t>FAQ-expansion</a:t>
+            </a:r>
+          </a:p>
+        </p:txBody>
+      </p:sp>
+      <p:sp>
+        <p:nvSpPr>
+          <p:cNvPr id="33" name="TextBox 32"/>
+          <p:cNvSpPr txBox="1"/>
+          <p:nvPr/>
+        </p:nvSpPr>
+        <p:spPr>
+          <a:xfrm>
+            <a:off x="6263640" y="4023360"/>
+            <a:ext cx="1097280" cy="228600"/>
+          </a:xfrm>
+          <a:prstGeom prst="rect">
+            <a:avLst/>
+          </a:prstGeom>
+          <a:noFill/>
+        </p:spPr>
+        <p:txBody>
+          <a:bodyPr wrap="square">
+            <a:spAutoFit/>
+          </a:bodyPr>
+          <a:lstStyle/>
+          <a:p>
+            <a:pPr algn="l">
+              <a:defRPr sz="1100" b="1">
+                <a:solidFill>
+                  <a:srgbClr val="DD3333"/>
+                </a:solidFill>
+                <a:latin typeface="Calibri"/>
+              </a:defRPr>
+            </a:pPr>
+            <a:r>
+              <a:t>30+ frågor</a:t>
+            </a:r>
+          </a:p>
+        </p:txBody>
+      </p:sp>
+      <p:sp>
+        <p:nvSpPr>
+          <p:cNvPr id="34" name="TextBox 33"/>
+          <p:cNvSpPr txBox="1"/>
+          <p:nvPr/>
+        </p:nvSpPr>
+        <p:spPr>
+          <a:xfrm>
+            <a:off x="6263640" y="4297680"/>
+            <a:ext cx="2377440" cy="640080"/>
+          </a:xfrm>
+          <a:prstGeom prst="rect">
+            <a:avLst/>
+          </a:prstGeom>
+          <a:noFill/>
+        </p:spPr>
+        <p:txBody>
+          <a:bodyPr wrap="square">
+            <a:spAutoFit/>
+          </a:bodyPr>
+          <a:lstStyle/>
+          <a:p>
+            <a:pPr algn="l">
+              <a:defRPr sz="1000" b="0">
+                <a:solidFill>
+                  <a:srgbClr val="999999"/>
+                </a:solidFill>
+                <a:latin typeface="Calibri"/>
+              </a:defRPr>
+            </a:pPr>
+            <a:r>
+              <a:t>Kostnad • Leveranstid</a:t>
+            </a:r>
+            <a:br/>
+            <a:r>
+              <a:t>Min-order • Legeringsval</a:t>
+            </a:r>
+          </a:p>
+        </p:txBody>
+      </p:sp>
+      <p:sp>
+        <p:nvSpPr>
+          <p:cNvPr id="35" name="TextBox 34"/>
+          <p:cNvSpPr txBox="1"/>
+          <p:nvPr/>
+        </p:nvSpPr>
+        <p:spPr>
+          <a:xfrm>
+            <a:off x="6263640" y="5029200"/>
+            <a:ext cx="2377440" cy="457200"/>
+          </a:xfrm>
+          <a:prstGeom prst="rect">
+            <a:avLst/>
+          </a:prstGeom>
+          <a:noFill/>
+        </p:spPr>
+        <p:txBody>
+          <a:bodyPr wrap="square">
+            <a:spAutoFit/>
+          </a:bodyPr>
+          <a:lstStyle/>
+          <a:p>
+            <a:pPr algn="l">
+              <a:defRPr sz="1000" b="0">
+                <a:solidFill>
+                  <a:srgbClr val="1A1A1A"/>
+                </a:solidFill>
+                <a:latin typeface="Calibri"/>
+              </a:defRPr>
+            </a:pPr>
+            <a:r>
+              <a:t>Featured snippets</a:t>
+            </a:r>
+            <a:br/>
+            <a:r>
+              <a:t>i Google</a:t>
+            </a:r>
+          </a:p>
+        </p:txBody>
+      </p:sp>
+      <p:sp>
+        <p:nvSpPr>
+          <p:cNvPr id="36" name="Rectangle 35"/>
+          <p:cNvSpPr/>
+          <p:nvPr/>
+        </p:nvSpPr>
+        <p:spPr>
+          <a:xfrm>
+            <a:off x="457200" y="5760720"/>
+            <a:ext cx="8229600" cy="548640"/>
+          </a:xfrm>
+          <a:prstGeom prst="rect">
+            <a:avLst/>
+          </a:prstGeom>
+          <a:solidFill>
+            <a:srgbClr val="1A1A1A"/>
+          </a:solidFill>
+          <a:ln>
+            <a:noFill/>
+          </a:ln>
+        </p:spPr>
+        <p:style>
+          <a:lnRef idx="1">
+            <a:schemeClr val="accent1"/>
+          </a:lnRef>
+          <a:fillRef idx="3">
+            <a:schemeClr val="accent1"/>
+          </a:fillRef>
+          <a:effectRef idx="2">
+            <a:schemeClr val="accent1"/>
+          </a:effectRef>
+          <a:fontRef idx="minor">
+            <a:schemeClr val="lt1"/>
+          </a:fontRef>
+        </p:style>
+        <p:txBody>
+          <a:bodyPr rtlCol="0" anchor="ctr"/>
+          <a:lstStyle/>
+          <a:p>
+            <a:pPr algn="ctr"/>
+          </a:p>
+        </p:txBody>
+      </p:sp>
+      <p:sp>
+        <p:nvSpPr>
+          <p:cNvPr id="37" name="TextBox 36"/>
+          <p:cNvSpPr txBox="1"/>
+          <p:nvPr/>
+        </p:nvSpPr>
+        <p:spPr>
+          <a:xfrm>
+            <a:off x="640080" y="5806440"/>
+            <a:ext cx="7772400" cy="365760"/>
+          </a:xfrm>
+          <a:prstGeom prst="rect">
+            <a:avLst/>
+          </a:prstGeom>
+          <a:noFill/>
+        </p:spPr>
+        <p:txBody>
+          <a:bodyPr wrap="square">
+            <a:spAutoFit/>
+          </a:bodyPr>
+          <a:lstStyle/>
+          <a:p>
+            <a:pPr algn="l">
+              <a:defRPr sz="1200" b="0">
+                <a:solidFill>
+                  <a:srgbClr val="FFFFFF"/>
+                </a:solidFill>
+                <a:latin typeface="Calibri"/>
+              </a:defRPr>
+            </a:pPr>
+            <a:r>
+              <a:t>Totalt: ~20 nya permanenta sidor  •  Uppskattad tid: 5-7 arbetsdagar  •  Ingen är blogg — alla bygger sajt-auktoritet</a:t>
+            </a:r>
+          </a:p>
+        </p:txBody>
+      </p:sp>
+    </p:spTree>
+  </p:cSld>
+  <p:clrMapOvr>
+    <a:masterClrMapping/>
+  </p:clrMapOvr>
+</p:sld>
+</file>
+
+<file path=ppt/slides/slide16.xml><?xml version="1.0" encoding="utf-8"?>
+<p:sld xmlns:a="http://schemas.openxmlformats.org/drawingml/2006/main" xmlns:p="http://schemas.openxmlformats.org/presentationml/2006/main" xmlns:r="http://schemas.openxmlformats.org/officeDocument/2006/relationships">
+  <p:cSld>
+    <p:bg>
+      <p:bgPr>
+        <a:solidFill>
+          <a:srgbClr val="FFFFFF"/>
+        </a:solidFill>
+        <a:effectLst/>
+      </p:bgPr>
+    </p:bg>
+    <p:spTree>
+      <p:nvGrpSpPr>
+        <p:cNvPr id="1" name=""/>
+        <p:cNvGrpSpPr/>
+        <p:nvPr/>
+      </p:nvGrpSpPr>
+      <p:grpSpPr/>
+      <p:sp>
+        <p:nvSpPr>
+          <p:cNvPr id="2" name="Rectangle 1"/>
+          <p:cNvSpPr/>
+          <p:nvPr/>
+        </p:nvSpPr>
+        <p:spPr>
+          <a:xfrm>
+            <a:off x="0" y="0"/>
+            <a:ext cx="9144000" cy="73152"/>
+          </a:xfrm>
+          <a:prstGeom prst="rect">
+            <a:avLst/>
+          </a:prstGeom>
+          <a:solidFill>
+            <a:srgbClr val="DD3333"/>
+          </a:solidFill>
+          <a:ln>
+            <a:noFill/>
+          </a:ln>
+        </p:spPr>
+        <p:style>
+          <a:lnRef idx="1">
+            <a:schemeClr val="accent1"/>
+          </a:lnRef>
+          <a:fillRef idx="3">
+            <a:schemeClr val="accent1"/>
+          </a:fillRef>
+          <a:effectRef idx="2">
+            <a:schemeClr val="accent1"/>
+          </a:effectRef>
+          <a:fontRef idx="minor">
+            <a:schemeClr val="lt1"/>
+          </a:fontRef>
+        </p:style>
+        <p:txBody>
+          <a:bodyPr rtlCol="0" anchor="ctr"/>
+          <a:lstStyle/>
+          <a:p>
+            <a:pPr algn="ctr"/>
+          </a:p>
+        </p:txBody>
+      </p:sp>
+      <p:sp>
+        <p:nvSpPr>
+          <p:cNvPr id="3" name="TextBox 2"/>
+          <p:cNvSpPr txBox="1"/>
+          <p:nvPr/>
+        </p:nvSpPr>
+        <p:spPr>
+          <a:xfrm>
+            <a:off x="457200" y="274320"/>
+            <a:ext cx="2743200" cy="274320"/>
+          </a:xfrm>
+          <a:prstGeom prst="rect">
+            <a:avLst/>
+          </a:prstGeom>
+          <a:noFill/>
+        </p:spPr>
+        <p:txBody>
+          <a:bodyPr wrap="square">
+            <a:spAutoFit/>
+          </a:bodyPr>
+          <a:lstStyle/>
+          <a:p>
+            <a:pPr algn="l">
+              <a:defRPr sz="1100" b="1">
+                <a:solidFill>
+                  <a:srgbClr val="DD3333"/>
+                </a:solidFill>
+                <a:latin typeface="Calibri"/>
+              </a:defRPr>
+            </a:pPr>
+            <a:r>
+              <a:t>TOPP-MÖJLIGHETER</a:t>
+            </a:r>
+          </a:p>
+        </p:txBody>
+      </p:sp>
+      <p:sp>
+        <p:nvSpPr>
+          <p:cNvPr id="4" name="TextBox 3"/>
+          <p:cNvSpPr txBox="1"/>
+          <p:nvPr/>
+        </p:nvSpPr>
+        <p:spPr>
+          <a:xfrm>
+            <a:off x="457200" y="548640"/>
+            <a:ext cx="7315200" cy="457200"/>
+          </a:xfrm>
+          <a:prstGeom prst="rect">
+            <a:avLst/>
+          </a:prstGeom>
+          <a:noFill/>
+        </p:spPr>
+        <p:txBody>
+          <a:bodyPr wrap="square">
+            <a:spAutoFit/>
+          </a:bodyPr>
+          <a:lstStyle/>
+          <a:p>
+            <a:pPr algn="l">
+              <a:defRPr sz="2800" b="1">
+                <a:solidFill>
+                  <a:srgbClr val="1A1A1A"/>
+                </a:solidFill>
+                <a:latin typeface="Calibri"/>
+              </a:defRPr>
+            </a:pPr>
+            <a:r>
+              <a:t>Konkreta sidor vi bygger nästa kvartal</a:t>
+            </a:r>
+          </a:p>
+        </p:txBody>
+      </p:sp>
+      <p:sp>
+        <p:nvSpPr>
+          <p:cNvPr id="5" name="TextBox 4"/>
+          <p:cNvSpPr txBox="1"/>
+          <p:nvPr/>
+        </p:nvSpPr>
+        <p:spPr>
+          <a:xfrm>
+            <a:off x="457200" y="1051560"/>
+            <a:ext cx="7315200" cy="365760"/>
+          </a:xfrm>
+          <a:prstGeom prst="rect">
+            <a:avLst/>
+          </a:prstGeom>
+          <a:noFill/>
+        </p:spPr>
+        <p:txBody>
+          <a:bodyPr wrap="square">
+            <a:spAutoFit/>
+          </a:bodyPr>
+          <a:lstStyle/>
+          <a:p>
+            <a:pPr algn="l">
+              <a:defRPr sz="1300" b="0">
+                <a:solidFill>
+                  <a:srgbClr val="999999"/>
+                </a:solidFill>
+                <a:latin typeface="Calibri"/>
+              </a:defRPr>
+            </a:pPr>
+            <a:r>
+              <a:t>Prioriterade efter sökvolym och konverteringspotential</a:t>
+            </a:r>
+          </a:p>
+        </p:txBody>
+      </p:sp>
+      <p:sp>
+        <p:nvSpPr>
+          <p:cNvPr id="6" name="TextBox 5"/>
+          <p:cNvSpPr txBox="1"/>
+          <p:nvPr/>
+        </p:nvSpPr>
+        <p:spPr>
+          <a:xfrm>
+            <a:off x="457200" y="1463040"/>
+            <a:ext cx="2926080" cy="274320"/>
+          </a:xfrm>
+          <a:prstGeom prst="rect">
+            <a:avLst/>
+          </a:prstGeom>
+          <a:noFill/>
+        </p:spPr>
+        <p:txBody>
+          <a:bodyPr wrap="square">
+            <a:spAutoFit/>
+          </a:bodyPr>
+          <a:lstStyle/>
+          <a:p>
+            <a:pPr algn="l">
+              <a:defRPr sz="1000" b="1">
+                <a:solidFill>
+                  <a:srgbClr val="DD3333"/>
+                </a:solidFill>
+                <a:latin typeface="Calibri"/>
+              </a:defRPr>
+            </a:pPr>
+            <a:r>
+              <a:t>SIDA</a:t>
+            </a:r>
+          </a:p>
+        </p:txBody>
+      </p:sp>
+      <p:sp>
+        <p:nvSpPr>
+          <p:cNvPr id="7" name="TextBox 6"/>
+          <p:cNvSpPr txBox="1"/>
+          <p:nvPr/>
+        </p:nvSpPr>
+        <p:spPr>
+          <a:xfrm>
+            <a:off x="3383280" y="1463040"/>
+            <a:ext cx="2286000" cy="274320"/>
+          </a:xfrm>
+          <a:prstGeom prst="rect">
+            <a:avLst/>
+          </a:prstGeom>
+          <a:noFill/>
+        </p:spPr>
+        <p:txBody>
+          <a:bodyPr wrap="square">
+            <a:spAutoFit/>
+          </a:bodyPr>
+          <a:lstStyle/>
+          <a:p>
+            <a:pPr algn="l">
+              <a:defRPr sz="1000" b="1">
+                <a:solidFill>
+                  <a:srgbClr val="DD3333"/>
+                </a:solidFill>
+                <a:latin typeface="Calibri"/>
+              </a:defRPr>
+            </a:pPr>
+            <a:r>
+              <a:t>URL</a:t>
+            </a:r>
+          </a:p>
+        </p:txBody>
+      </p:sp>
+      <p:sp>
+        <p:nvSpPr>
+          <p:cNvPr id="8" name="TextBox 7"/>
+          <p:cNvSpPr txBox="1"/>
+          <p:nvPr/>
+        </p:nvSpPr>
+        <p:spPr>
+          <a:xfrm>
+            <a:off x="5669280" y="1463040"/>
+            <a:ext cx="1371600" cy="274320"/>
+          </a:xfrm>
+          <a:prstGeom prst="rect">
+            <a:avLst/>
+          </a:prstGeom>
+          <a:noFill/>
+        </p:spPr>
+        <p:txBody>
+          <a:bodyPr wrap="square">
+            <a:spAutoFit/>
+          </a:bodyPr>
+          <a:lstStyle/>
+          <a:p>
+            <a:pPr algn="l">
+              <a:defRPr sz="1000" b="1">
+                <a:solidFill>
+                  <a:srgbClr val="DD3333"/>
+                </a:solidFill>
+                <a:latin typeface="Calibri"/>
+              </a:defRPr>
+            </a:pPr>
+            <a:r>
+              <a:t>SÖKVOLYM</a:t>
+            </a:r>
+          </a:p>
+        </p:txBody>
+      </p:sp>
+      <p:sp>
+        <p:nvSpPr>
+          <p:cNvPr id="9" name="TextBox 8"/>
+          <p:cNvSpPr txBox="1"/>
+          <p:nvPr/>
+        </p:nvSpPr>
+        <p:spPr>
+          <a:xfrm>
+            <a:off x="7040880" y="1463040"/>
+            <a:ext cx="1828800" cy="274320"/>
+          </a:xfrm>
+          <a:prstGeom prst="rect">
+            <a:avLst/>
+          </a:prstGeom>
+          <a:noFill/>
+        </p:spPr>
+        <p:txBody>
+          <a:bodyPr wrap="square">
+            <a:spAutoFit/>
+          </a:bodyPr>
+          <a:lstStyle/>
+          <a:p>
+            <a:pPr algn="l">
+              <a:defRPr sz="1000" b="1">
+                <a:solidFill>
+                  <a:srgbClr val="DD3333"/>
+                </a:solidFill>
+                <a:latin typeface="Calibri"/>
+              </a:defRPr>
+            </a:pPr>
+            <a:r>
+              <a:t>SYFTE</a:t>
+            </a:r>
+          </a:p>
+        </p:txBody>
+      </p:sp>
+      <p:sp>
+        <p:nvSpPr>
+          <p:cNvPr id="10" name="Rectangle 9"/>
+          <p:cNvSpPr/>
+          <p:nvPr/>
+        </p:nvSpPr>
+        <p:spPr>
+          <a:xfrm>
+            <a:off x="457200" y="1737360"/>
+            <a:ext cx="8229600" cy="18288"/>
+          </a:xfrm>
+          <a:prstGeom prst="rect">
+            <a:avLst/>
+          </a:prstGeom>
+          <a:solidFill>
+            <a:srgbClr val="DD3333"/>
+          </a:solidFill>
+          <a:ln>
+            <a:noFill/>
+          </a:ln>
+        </p:spPr>
+        <p:style>
+          <a:lnRef idx="1">
+            <a:schemeClr val="accent1"/>
+          </a:lnRef>
+          <a:fillRef idx="3">
+            <a:schemeClr val="accent1"/>
+          </a:fillRef>
+          <a:effectRef idx="2">
+            <a:schemeClr val="accent1"/>
+          </a:effectRef>
+          <a:fontRef idx="minor">
+            <a:schemeClr val="lt1"/>
+          </a:fontRef>
+        </p:style>
+        <p:txBody>
+          <a:bodyPr rtlCol="0" anchor="ctr"/>
+          <a:lstStyle/>
+          <a:p>
+            <a:pPr algn="ctr"/>
+          </a:p>
+        </p:txBody>
+      </p:sp>
+      <p:sp>
+        <p:nvSpPr>
+          <p:cNvPr id="11" name="Rectangle 10"/>
+          <p:cNvSpPr/>
+          <p:nvPr/>
+        </p:nvSpPr>
+        <p:spPr>
+          <a:xfrm>
+            <a:off x="457200" y="1847088"/>
+            <a:ext cx="8229600" cy="438912"/>
+          </a:xfrm>
+          <a:prstGeom prst="rect">
+            <a:avLst/>
+          </a:prstGeom>
+          <a:solidFill>
+            <a:srgbClr val="F5F5F5"/>
+          </a:solidFill>
+          <a:ln>
+            <a:noFill/>
+          </a:ln>
+        </p:spPr>
+        <p:style>
+          <a:lnRef idx="1">
+            <a:schemeClr val="accent1"/>
+          </a:lnRef>
+          <a:fillRef idx="3">
+            <a:schemeClr val="accent1"/>
+          </a:fillRef>
+          <a:effectRef idx="2">
+            <a:schemeClr val="accent1"/>
+          </a:effectRef>
+          <a:fontRef idx="minor">
+            <a:schemeClr val="lt1"/>
+          </a:fontRef>
+        </p:style>
+        <p:txBody>
+          <a:bodyPr rtlCol="0" anchor="ctr"/>
+          <a:lstStyle/>
+          <a:p>
+            <a:pPr algn="ctr"/>
+          </a:p>
+        </p:txBody>
+      </p:sp>
+      <p:sp>
+        <p:nvSpPr>
+          <p:cNvPr id="12" name="TextBox 11"/>
+          <p:cNvSpPr txBox="1"/>
+          <p:nvPr/>
+        </p:nvSpPr>
+        <p:spPr>
+          <a:xfrm>
+            <a:off x="548640" y="1874519"/>
+            <a:ext cx="2743200" cy="365760"/>
+          </a:xfrm>
+          <a:prstGeom prst="rect">
+            <a:avLst/>
+          </a:prstGeom>
+          <a:noFill/>
+        </p:spPr>
+        <p:txBody>
+          <a:bodyPr wrap="square">
+            <a:spAutoFit/>
+          </a:bodyPr>
+          <a:lstStyle/>
+          <a:p>
+            <a:pPr algn="l">
+              <a:defRPr sz="1100" b="1">
+                <a:solidFill>
+                  <a:srgbClr val="1A1A1A"/>
+                </a:solidFill>
+                <a:latin typeface="Calibri"/>
+              </a:defRPr>
+            </a:pPr>
+            <a:r>
+              <a:t>Gjutning fordonsindustrin</a:t>
+            </a:r>
+          </a:p>
+        </p:txBody>
+      </p:sp>
+      <p:sp>
+        <p:nvSpPr>
+          <p:cNvPr id="13" name="TextBox 12"/>
+          <p:cNvSpPr txBox="1"/>
+          <p:nvPr/>
+        </p:nvSpPr>
+        <p:spPr>
+          <a:xfrm>
+            <a:off x="3383280" y="1874519"/>
+            <a:ext cx="2286000" cy="365760"/>
+          </a:xfrm>
+          <a:prstGeom prst="rect">
+            <a:avLst/>
+          </a:prstGeom>
+          <a:noFill/>
+        </p:spPr>
+        <p:txBody>
+          <a:bodyPr wrap="square">
+            <a:spAutoFit/>
+          </a:bodyPr>
+          <a:lstStyle/>
+          <a:p>
+            <a:pPr algn="l">
+              <a:defRPr sz="900" b="0">
+                <a:solidFill>
+                  <a:srgbClr val="999999"/>
+                </a:solidFill>
+                <a:latin typeface="Calibri"/>
+              </a:defRPr>
+            </a:pPr>
+            <a:r>
+              <a:t>/branscher/fordon/</a:t>
+            </a:r>
+          </a:p>
+        </p:txBody>
+      </p:sp>
+      <p:sp>
+        <p:nvSpPr>
+          <p:cNvPr id="14" name="TextBox 13"/>
+          <p:cNvSpPr txBox="1"/>
+          <p:nvPr/>
+        </p:nvSpPr>
+        <p:spPr>
+          <a:xfrm>
+            <a:off x="5669280" y="1874519"/>
+            <a:ext cx="1371600" cy="365760"/>
+          </a:xfrm>
+          <a:prstGeom prst="rect">
+            <a:avLst/>
+          </a:prstGeom>
+          <a:noFill/>
+        </p:spPr>
+        <p:txBody>
+          <a:bodyPr wrap="square">
+            <a:spAutoFit/>
+          </a:bodyPr>
+          <a:lstStyle/>
+          <a:p>
+            <a:pPr algn="l">
+              <a:defRPr sz="1100" b="1">
+                <a:solidFill>
+                  <a:srgbClr val="DD3333"/>
+                </a:solidFill>
+                <a:latin typeface="Calibri"/>
+              </a:defRPr>
+            </a:pPr>
+            <a:r>
+              <a:t>100-200/mån</a:t>
+            </a:r>
+          </a:p>
+        </p:txBody>
+      </p:sp>
+      <p:sp>
+        <p:nvSpPr>
+          <p:cNvPr id="15" name="TextBox 14"/>
+          <p:cNvSpPr txBox="1"/>
+          <p:nvPr/>
+        </p:nvSpPr>
+        <p:spPr>
+          <a:xfrm>
+            <a:off x="7040880" y="1874519"/>
+            <a:ext cx="1828800" cy="365760"/>
+          </a:xfrm>
+          <a:prstGeom prst="rect">
+            <a:avLst/>
+          </a:prstGeom>
+          <a:noFill/>
+        </p:spPr>
+        <p:txBody>
+          <a:bodyPr wrap="square">
+            <a:spAutoFit/>
+          </a:bodyPr>
+          <a:lstStyle/>
+          <a:p>
+            <a:pPr algn="l">
+              <a:defRPr sz="1000" b="0">
+                <a:solidFill>
+                  <a:srgbClr val="1A1A1A"/>
+                </a:solidFill>
+                <a:latin typeface="Calibri"/>
+              </a:defRPr>
+            </a:pPr>
+            <a:r>
+              <a:t>B2B-beslutsfattare inom fordon</a:t>
+            </a:r>
+          </a:p>
+        </p:txBody>
+      </p:sp>
+      <p:sp>
+        <p:nvSpPr>
+          <p:cNvPr id="16" name="Rectangle 15"/>
+          <p:cNvSpPr/>
+          <p:nvPr/>
+        </p:nvSpPr>
+        <p:spPr>
+          <a:xfrm>
+            <a:off x="457200" y="2322576"/>
+            <a:ext cx="8229600" cy="438912"/>
+          </a:xfrm>
+          <a:prstGeom prst="rect">
+            <a:avLst/>
+          </a:prstGeom>
+          <a:solidFill>
+            <a:srgbClr val="FFFFFF"/>
+          </a:solidFill>
+          <a:ln>
+            <a:noFill/>
+          </a:ln>
+        </p:spPr>
+        <p:style>
+          <a:lnRef idx="1">
+            <a:schemeClr val="accent1"/>
+          </a:lnRef>
+          <a:fillRef idx="3">
+            <a:schemeClr val="accent1"/>
+          </a:fillRef>
+          <a:effectRef idx="2">
+            <a:schemeClr val="accent1"/>
+          </a:effectRef>
+          <a:fontRef idx="minor">
+            <a:schemeClr val="lt1"/>
+          </a:fontRef>
+        </p:style>
+        <p:txBody>
+          <a:bodyPr rtlCol="0" anchor="ctr"/>
+          <a:lstStyle/>
+          <a:p>
+            <a:pPr algn="ctr"/>
+          </a:p>
+        </p:txBody>
+      </p:sp>
+      <p:sp>
+        <p:nvSpPr>
+          <p:cNvPr id="17" name="TextBox 16"/>
+          <p:cNvSpPr txBox="1"/>
+          <p:nvPr/>
+        </p:nvSpPr>
+        <p:spPr>
+          <a:xfrm>
+            <a:off x="548640" y="2350008"/>
+            <a:ext cx="2743200" cy="365760"/>
+          </a:xfrm>
+          <a:prstGeom prst="rect">
+            <a:avLst/>
+          </a:prstGeom>
+          <a:noFill/>
+        </p:spPr>
+        <p:txBody>
+          <a:bodyPr wrap="square">
+            <a:spAutoFit/>
+          </a:bodyPr>
+          <a:lstStyle/>
+          <a:p>
+            <a:pPr algn="l">
+              <a:defRPr sz="1100" b="1">
+                <a:solidFill>
+                  <a:srgbClr val="1A1A1A"/>
+                </a:solidFill>
+                <a:latin typeface="Calibri"/>
+              </a:defRPr>
+            </a:pPr>
+            <a:r>
+              <a:t>CNC vs gjutning — när lönar sig vad?</a:t>
+            </a:r>
+          </a:p>
+        </p:txBody>
+      </p:sp>
+      <p:sp>
+        <p:nvSpPr>
+          <p:cNvPr id="18" name="TextBox 17"/>
+          <p:cNvSpPr txBox="1"/>
+          <p:nvPr/>
+        </p:nvSpPr>
+        <p:spPr>
+          <a:xfrm>
+            <a:off x="3383280" y="2350008"/>
+            <a:ext cx="2286000" cy="365760"/>
+          </a:xfrm>
+          <a:prstGeom prst="rect">
+            <a:avLst/>
+          </a:prstGeom>
+          <a:noFill/>
+        </p:spPr>
+        <p:txBody>
+          <a:bodyPr wrap="square">
+            <a:spAutoFit/>
+          </a:bodyPr>
+          <a:lstStyle/>
+          <a:p>
+            <a:pPr algn="l">
+              <a:defRPr sz="900" b="0">
+                <a:solidFill>
+                  <a:srgbClr val="999999"/>
+                </a:solidFill>
+                <a:latin typeface="Calibri"/>
+              </a:defRPr>
+            </a:pPr>
+            <a:r>
+              <a:t>/jamfor/cnc-vs-gjutning/</a:t>
+            </a:r>
+          </a:p>
+        </p:txBody>
+      </p:sp>
+      <p:sp>
+        <p:nvSpPr>
+          <p:cNvPr id="19" name="TextBox 18"/>
+          <p:cNvSpPr txBox="1"/>
+          <p:nvPr/>
+        </p:nvSpPr>
+        <p:spPr>
+          <a:xfrm>
+            <a:off x="5669280" y="2350008"/>
+            <a:ext cx="1371600" cy="365760"/>
+          </a:xfrm>
+          <a:prstGeom prst="rect">
+            <a:avLst/>
+          </a:prstGeom>
+          <a:noFill/>
+        </p:spPr>
+        <p:txBody>
+          <a:bodyPr wrap="square">
+            <a:spAutoFit/>
+          </a:bodyPr>
+          <a:lstStyle/>
+          <a:p>
+            <a:pPr algn="l">
+              <a:defRPr sz="1100" b="1">
+                <a:solidFill>
+                  <a:srgbClr val="DD3333"/>
+                </a:solidFill>
+                <a:latin typeface="Calibri"/>
+              </a:defRPr>
+            </a:pPr>
+            <a:r>
+              <a:t>80-150/mån</a:t>
+            </a:r>
+          </a:p>
+        </p:txBody>
+      </p:sp>
+      <p:sp>
+        <p:nvSpPr>
+          <p:cNvPr id="20" name="TextBox 19"/>
+          <p:cNvSpPr txBox="1"/>
+          <p:nvPr/>
+        </p:nvSpPr>
+        <p:spPr>
+          <a:xfrm>
+            <a:off x="7040880" y="2350008"/>
+            <a:ext cx="1828800" cy="365760"/>
+          </a:xfrm>
+          <a:prstGeom prst="rect">
+            <a:avLst/>
+          </a:prstGeom>
+          <a:noFill/>
+        </p:spPr>
+        <p:txBody>
+          <a:bodyPr wrap="square">
+            <a:spAutoFit/>
+          </a:bodyPr>
+          <a:lstStyle/>
+          <a:p>
+            <a:pPr algn="l">
+              <a:defRPr sz="1000" b="0">
+                <a:solidFill>
+                  <a:srgbClr val="1A1A1A"/>
+                </a:solidFill>
+                <a:latin typeface="Calibri"/>
+              </a:defRPr>
+            </a:pPr>
+            <a:r>
+              <a:t>Ingenjörer som utvärderar</a:t>
+            </a:r>
+          </a:p>
+        </p:txBody>
+      </p:sp>
+      <p:sp>
+        <p:nvSpPr>
+          <p:cNvPr id="21" name="Rectangle 20"/>
+          <p:cNvSpPr/>
+          <p:nvPr/>
+        </p:nvSpPr>
+        <p:spPr>
+          <a:xfrm>
+            <a:off x="457200" y="2798064"/>
+            <a:ext cx="8229600" cy="438912"/>
+          </a:xfrm>
+          <a:prstGeom prst="rect">
+            <a:avLst/>
+          </a:prstGeom>
+          <a:solidFill>
+            <a:srgbClr val="F5F5F5"/>
+          </a:solidFill>
+          <a:ln>
+            <a:noFill/>
+          </a:ln>
+        </p:spPr>
+        <p:style>
+          <a:lnRef idx="1">
+            <a:schemeClr val="accent1"/>
+          </a:lnRef>
+          <a:fillRef idx="3">
+            <a:schemeClr val="accent1"/>
+          </a:fillRef>
+          <a:effectRef idx="2">
+            <a:schemeClr val="accent1"/>
+          </a:effectRef>
+          <a:fontRef idx="minor">
+            <a:schemeClr val="lt1"/>
+          </a:fontRef>
+        </p:style>
+        <p:txBody>
+          <a:bodyPr rtlCol="0" anchor="ctr"/>
+          <a:lstStyle/>
+          <a:p>
+            <a:pPr algn="ctr"/>
+          </a:p>
+        </p:txBody>
+      </p:sp>
+      <p:sp>
+        <p:nvSpPr>
+          <p:cNvPr id="22" name="TextBox 21"/>
+          <p:cNvSpPr txBox="1"/>
+          <p:nvPr/>
+        </p:nvSpPr>
+        <p:spPr>
+          <a:xfrm>
+            <a:off x="548640" y="2825496"/>
+            <a:ext cx="2743200" cy="365760"/>
+          </a:xfrm>
+          <a:prstGeom prst="rect">
+            <a:avLst/>
+          </a:prstGeom>
+          <a:noFill/>
+        </p:spPr>
+        <p:txBody>
+          <a:bodyPr wrap="square">
+            <a:spAutoFit/>
+          </a:bodyPr>
+          <a:lstStyle/>
+          <a:p>
+            <a:pPr algn="l">
+              <a:defRPr sz="1100" b="1">
+                <a:solidFill>
+                  <a:srgbClr val="1A1A1A"/>
+                </a:solidFill>
+                <a:latin typeface="Calibri"/>
+              </a:defRPr>
+            </a:pPr>
+            <a:r>
+              <a:t>Gjutning vs 3D-print metall</a:t>
+            </a:r>
+          </a:p>
+        </p:txBody>
+      </p:sp>
+      <p:sp>
+        <p:nvSpPr>
+          <p:cNvPr id="23" name="TextBox 22"/>
+          <p:cNvSpPr txBox="1"/>
+          <p:nvPr/>
+        </p:nvSpPr>
+        <p:spPr>
+          <a:xfrm>
+            <a:off x="3383280" y="2825496"/>
+            <a:ext cx="2286000" cy="365760"/>
+          </a:xfrm>
+          <a:prstGeom prst="rect">
+            <a:avLst/>
+          </a:prstGeom>
+          <a:noFill/>
+        </p:spPr>
+        <p:txBody>
+          <a:bodyPr wrap="square">
+            <a:spAutoFit/>
+          </a:bodyPr>
+          <a:lstStyle/>
+          <a:p>
+            <a:pPr algn="l">
+              <a:defRPr sz="900" b="0">
+                <a:solidFill>
+                  <a:srgbClr val="999999"/>
+                </a:solidFill>
+                <a:latin typeface="Calibri"/>
+              </a:defRPr>
+            </a:pPr>
+            <a:r>
+              <a:t>/jamfor/gjutning-vs-3d-print/</a:t>
+            </a:r>
+          </a:p>
+        </p:txBody>
+      </p:sp>
+      <p:sp>
+        <p:nvSpPr>
+          <p:cNvPr id="24" name="TextBox 23"/>
+          <p:cNvSpPr txBox="1"/>
+          <p:nvPr/>
+        </p:nvSpPr>
+        <p:spPr>
+          <a:xfrm>
+            <a:off x="5669280" y="2825496"/>
+            <a:ext cx="1371600" cy="365760"/>
+          </a:xfrm>
+          <a:prstGeom prst="rect">
+            <a:avLst/>
+          </a:prstGeom>
+          <a:noFill/>
+        </p:spPr>
+        <p:txBody>
+          <a:bodyPr wrap="square">
+            <a:spAutoFit/>
+          </a:bodyPr>
+          <a:lstStyle/>
+          <a:p>
+            <a:pPr algn="l">
+              <a:defRPr sz="1100" b="1">
+                <a:solidFill>
+                  <a:srgbClr val="DD3333"/>
+                </a:solidFill>
+                <a:latin typeface="Calibri"/>
+              </a:defRPr>
+            </a:pPr>
+            <a:r>
+              <a:t>60-120/mån</a:t>
+            </a:r>
+          </a:p>
+        </p:txBody>
+      </p:sp>
+      <p:sp>
+        <p:nvSpPr>
+          <p:cNvPr id="25" name="TextBox 24"/>
+          <p:cNvSpPr txBox="1"/>
+          <p:nvPr/>
+        </p:nvSpPr>
+        <p:spPr>
+          <a:xfrm>
+            <a:off x="7040880" y="2825496"/>
+            <a:ext cx="1828800" cy="365760"/>
+          </a:xfrm>
+          <a:prstGeom prst="rect">
+            <a:avLst/>
+          </a:prstGeom>
+          <a:noFill/>
+        </p:spPr>
+        <p:txBody>
+          <a:bodyPr wrap="square">
+            <a:spAutoFit/>
+          </a:bodyPr>
+          <a:lstStyle/>
+          <a:p>
+            <a:pPr algn="l">
+              <a:defRPr sz="1000" b="0">
+                <a:solidFill>
+                  <a:srgbClr val="1A1A1A"/>
+                </a:solidFill>
+                <a:latin typeface="Calibri"/>
+              </a:defRPr>
+            </a:pPr>
+            <a:r>
+              <a:t>Trending — framtidsinriktat</a:t>
+            </a:r>
+          </a:p>
+        </p:txBody>
+      </p:sp>
+      <p:sp>
+        <p:nvSpPr>
+          <p:cNvPr id="26" name="Rectangle 25"/>
+          <p:cNvSpPr/>
+          <p:nvPr/>
+        </p:nvSpPr>
+        <p:spPr>
+          <a:xfrm>
+            <a:off x="457200" y="3273552"/>
+            <a:ext cx="8229600" cy="438912"/>
+          </a:xfrm>
+          <a:prstGeom prst="rect">
+            <a:avLst/>
+          </a:prstGeom>
+          <a:solidFill>
+            <a:srgbClr val="FFFFFF"/>
+          </a:solidFill>
+          <a:ln>
+            <a:noFill/>
+          </a:ln>
+        </p:spPr>
+        <p:style>
+          <a:lnRef idx="1">
+            <a:schemeClr val="accent1"/>
+          </a:lnRef>
+          <a:fillRef idx="3">
+            <a:schemeClr val="accent1"/>
+          </a:fillRef>
+          <a:effectRef idx="2">
+            <a:schemeClr val="accent1"/>
+          </a:effectRef>
+          <a:fontRef idx="minor">
+            <a:schemeClr val="lt1"/>
+          </a:fontRef>
+        </p:style>
+        <p:txBody>
+          <a:bodyPr rtlCol="0" anchor="ctr"/>
+          <a:lstStyle/>
+          <a:p>
+            <a:pPr algn="ctr"/>
+          </a:p>
+        </p:txBody>
+      </p:sp>
+      <p:sp>
+        <p:nvSpPr>
+          <p:cNvPr id="27" name="TextBox 26"/>
+          <p:cNvSpPr txBox="1"/>
+          <p:nvPr/>
+        </p:nvSpPr>
+        <p:spPr>
+          <a:xfrm>
+            <a:off x="548640" y="3300984"/>
+            <a:ext cx="2743200" cy="365760"/>
+          </a:xfrm>
+          <a:prstGeom prst="rect">
+            <a:avLst/>
+          </a:prstGeom>
+          <a:noFill/>
+        </p:spPr>
+        <p:txBody>
+          <a:bodyPr wrap="square">
+            <a:spAutoFit/>
+          </a:bodyPr>
+          <a:lstStyle/>
+          <a:p>
+            <a:pPr algn="l">
+              <a:defRPr sz="1100" b="1">
+                <a:solidFill>
+                  <a:srgbClr val="1A1A1A"/>
+                </a:solidFill>
+                <a:latin typeface="Calibri"/>
+              </a:defRPr>
+            </a:pPr>
+            <a:r>
+              <a:t>Gjuteri Sverige — översikt</a:t>
+            </a:r>
+          </a:p>
+        </p:txBody>
+      </p:sp>
+      <p:sp>
+        <p:nvSpPr>
+          <p:cNvPr id="28" name="TextBox 27"/>
+          <p:cNvSpPr txBox="1"/>
+          <p:nvPr/>
+        </p:nvSpPr>
+        <p:spPr>
+          <a:xfrm>
+            <a:off x="3383280" y="3300984"/>
+            <a:ext cx="2286000" cy="365760"/>
+          </a:xfrm>
+          <a:prstGeom prst="rect">
+            <a:avLst/>
+          </a:prstGeom>
+          <a:noFill/>
+        </p:spPr>
+        <p:txBody>
+          <a:bodyPr wrap="square">
+            <a:spAutoFit/>
+          </a:bodyPr>
+          <a:lstStyle/>
+          <a:p>
+            <a:pPr algn="l">
+              <a:defRPr sz="900" b="0">
+                <a:solidFill>
+                  <a:srgbClr val="999999"/>
+                </a:solidFill>
+                <a:latin typeface="Calibri"/>
+              </a:defRPr>
+            </a:pPr>
+            <a:r>
+              <a:t>/gjuteri-sverige/</a:t>
+            </a:r>
+          </a:p>
+        </p:txBody>
+      </p:sp>
+      <p:sp>
+        <p:nvSpPr>
+          <p:cNvPr id="29" name="TextBox 28"/>
+          <p:cNvSpPr txBox="1"/>
+          <p:nvPr/>
+        </p:nvSpPr>
+        <p:spPr>
+          <a:xfrm>
+            <a:off x="5669280" y="3300984"/>
+            <a:ext cx="1371600" cy="365760"/>
+          </a:xfrm>
+          <a:prstGeom prst="rect">
+            <a:avLst/>
+          </a:prstGeom>
+          <a:noFill/>
+        </p:spPr>
+        <p:txBody>
+          <a:bodyPr wrap="square">
+            <a:spAutoFit/>
+          </a:bodyPr>
+          <a:lstStyle/>
+          <a:p>
+            <a:pPr algn="l">
+              <a:defRPr sz="1100" b="1">
+                <a:solidFill>
+                  <a:srgbClr val="DD3333"/>
+                </a:solidFill>
+                <a:latin typeface="Calibri"/>
+              </a:defRPr>
+            </a:pPr>
+            <a:r>
+              <a:t>90-170/mån</a:t>
+            </a:r>
+          </a:p>
+        </p:txBody>
+      </p:sp>
+      <p:sp>
+        <p:nvSpPr>
+          <p:cNvPr id="30" name="TextBox 29"/>
+          <p:cNvSpPr txBox="1"/>
+          <p:nvPr/>
+        </p:nvSpPr>
+        <p:spPr>
+          <a:xfrm>
+            <a:off x="7040880" y="3300984"/>
+            <a:ext cx="1828800" cy="365760"/>
+          </a:xfrm>
+          <a:prstGeom prst="rect">
+            <a:avLst/>
+          </a:prstGeom>
+          <a:noFill/>
+        </p:spPr>
+        <p:txBody>
+          <a:bodyPr wrap="square">
+            <a:spAutoFit/>
+          </a:bodyPr>
+          <a:lstStyle/>
+          <a:p>
+            <a:pPr algn="l">
+              <a:defRPr sz="1000" b="0">
+                <a:solidFill>
+                  <a:srgbClr val="1A1A1A"/>
+                </a:solidFill>
+                <a:latin typeface="Calibri"/>
+              </a:defRPr>
+            </a:pPr>
+            <a:r>
+              <a:t>Geo-sökning, nära offert</a:t>
+            </a:r>
+          </a:p>
+        </p:txBody>
+      </p:sp>
+      <p:sp>
+        <p:nvSpPr>
+          <p:cNvPr id="31" name="Rectangle 30"/>
+          <p:cNvSpPr/>
+          <p:nvPr/>
+        </p:nvSpPr>
+        <p:spPr>
+          <a:xfrm>
+            <a:off x="457200" y="3749039"/>
+            <a:ext cx="8229600" cy="438912"/>
+          </a:xfrm>
+          <a:prstGeom prst="rect">
+            <a:avLst/>
+          </a:prstGeom>
+          <a:solidFill>
+            <a:srgbClr val="F5F5F5"/>
+          </a:solidFill>
+          <a:ln>
+            <a:noFill/>
+          </a:ln>
+        </p:spPr>
+        <p:style>
+          <a:lnRef idx="1">
+            <a:schemeClr val="accent1"/>
+          </a:lnRef>
+          <a:fillRef idx="3">
+            <a:schemeClr val="accent1"/>
+          </a:fillRef>
+          <a:effectRef idx="2">
+            <a:schemeClr val="accent1"/>
+          </a:effectRef>
+          <a:fontRef idx="minor">
+            <a:schemeClr val="lt1"/>
+          </a:fontRef>
+        </p:style>
+        <p:txBody>
+          <a:bodyPr rtlCol="0" anchor="ctr"/>
+          <a:lstStyle/>
+          <a:p>
+            <a:pPr algn="ctr"/>
+          </a:p>
+        </p:txBody>
+      </p:sp>
+      <p:sp>
+        <p:nvSpPr>
+          <p:cNvPr id="32" name="TextBox 31"/>
+          <p:cNvSpPr txBox="1"/>
+          <p:nvPr/>
+        </p:nvSpPr>
+        <p:spPr>
+          <a:xfrm>
+            <a:off x="548640" y="3776472"/>
+            <a:ext cx="2743200" cy="365760"/>
+          </a:xfrm>
+          <a:prstGeom prst="rect">
+            <a:avLst/>
+          </a:prstGeom>
+          <a:noFill/>
+        </p:spPr>
+        <p:txBody>
+          <a:bodyPr wrap="square">
+            <a:spAutoFit/>
+          </a:bodyPr>
+          <a:lstStyle/>
+          <a:p>
+            <a:pPr algn="l">
+              <a:defRPr sz="1100" b="1">
+                <a:solidFill>
+                  <a:srgbClr val="1A1A1A"/>
+                </a:solidFill>
+                <a:latin typeface="Calibri"/>
+              </a:defRPr>
+            </a:pPr>
+            <a:r>
+              <a:t>Materialguiden</a:t>
+            </a:r>
+          </a:p>
+        </p:txBody>
+      </p:sp>
+      <p:sp>
+        <p:nvSpPr>
+          <p:cNvPr id="33" name="TextBox 32"/>
+          <p:cNvSpPr txBox="1"/>
+          <p:nvPr/>
+        </p:nvSpPr>
+        <p:spPr>
+          <a:xfrm>
+            <a:off x="3383280" y="3776472"/>
+            <a:ext cx="2286000" cy="365760"/>
+          </a:xfrm>
+          <a:prstGeom prst="rect">
+            <a:avLst/>
+          </a:prstGeom>
+          <a:noFill/>
+        </p:spPr>
+        <p:txBody>
+          <a:bodyPr wrap="square">
+            <a:spAutoFit/>
+          </a:bodyPr>
+          <a:lstStyle/>
+          <a:p>
+            <a:pPr algn="l">
+              <a:defRPr sz="900" b="0">
+                <a:solidFill>
+                  <a:srgbClr val="999999"/>
+                </a:solidFill>
+                <a:latin typeface="Calibri"/>
+              </a:defRPr>
+            </a:pPr>
+            <a:r>
+              <a:t>/guider/materialguiden/</a:t>
+            </a:r>
+          </a:p>
+        </p:txBody>
+      </p:sp>
+      <p:sp>
+        <p:nvSpPr>
+          <p:cNvPr id="34" name="TextBox 33"/>
+          <p:cNvSpPr txBox="1"/>
+          <p:nvPr/>
+        </p:nvSpPr>
+        <p:spPr>
+          <a:xfrm>
+            <a:off x="5669280" y="3776472"/>
+            <a:ext cx="1371600" cy="365760"/>
+          </a:xfrm>
+          <a:prstGeom prst="rect">
+            <a:avLst/>
+          </a:prstGeom>
+          <a:noFill/>
+        </p:spPr>
+        <p:txBody>
+          <a:bodyPr wrap="square">
+            <a:spAutoFit/>
+          </a:bodyPr>
+          <a:lstStyle/>
+          <a:p>
+            <a:pPr algn="l">
+              <a:defRPr sz="1100" b="1">
+                <a:solidFill>
+                  <a:srgbClr val="DD3333"/>
+                </a:solidFill>
+                <a:latin typeface="Calibri"/>
+              </a:defRPr>
+            </a:pPr>
+            <a:r>
+              <a:t>Lead magnet</a:t>
+            </a:r>
+          </a:p>
+        </p:txBody>
+      </p:sp>
+      <p:sp>
+        <p:nvSpPr>
+          <p:cNvPr id="35" name="TextBox 34"/>
+          <p:cNvSpPr txBox="1"/>
+          <p:nvPr/>
+        </p:nvSpPr>
+        <p:spPr>
+          <a:xfrm>
+            <a:off x="7040880" y="3776472"/>
+            <a:ext cx="1828800" cy="365760"/>
+          </a:xfrm>
+          <a:prstGeom prst="rect">
+            <a:avLst/>
+          </a:prstGeom>
+          <a:noFill/>
+        </p:spPr>
+        <p:txBody>
+          <a:bodyPr wrap="square">
+            <a:spAutoFit/>
+          </a:bodyPr>
+          <a:lstStyle/>
+          <a:p>
+            <a:pPr algn="l">
+              <a:defRPr sz="1000" b="0">
+                <a:solidFill>
+                  <a:srgbClr val="1A1A1A"/>
+                </a:solidFill>
+                <a:latin typeface="Calibri"/>
+              </a:defRPr>
+            </a:pPr>
+            <a:r>
+              <a:t>Offertformulär i botten</a:t>
+            </a:r>
+          </a:p>
+        </p:txBody>
+      </p:sp>
+      <p:sp>
+        <p:nvSpPr>
+          <p:cNvPr id="36" name="Rectangle 35"/>
+          <p:cNvSpPr/>
+          <p:nvPr/>
+        </p:nvSpPr>
+        <p:spPr>
+          <a:xfrm>
+            <a:off x="457200" y="4224528"/>
+            <a:ext cx="8229600" cy="438912"/>
+          </a:xfrm>
+          <a:prstGeom prst="rect">
+            <a:avLst/>
+          </a:prstGeom>
+          <a:solidFill>
+            <a:srgbClr val="FFFFFF"/>
+          </a:solidFill>
+          <a:ln>
+            <a:noFill/>
+          </a:ln>
+        </p:spPr>
+        <p:style>
+          <a:lnRef idx="1">
+            <a:schemeClr val="accent1"/>
+          </a:lnRef>
+          <a:fillRef idx="3">
+            <a:schemeClr val="accent1"/>
+          </a:fillRef>
+          <a:effectRef idx="2">
+            <a:schemeClr val="accent1"/>
+          </a:effectRef>
+          <a:fontRef idx="minor">
+            <a:schemeClr val="lt1"/>
+          </a:fontRef>
+        </p:style>
+        <p:txBody>
+          <a:bodyPr rtlCol="0" anchor="ctr"/>
+          <a:lstStyle/>
+          <a:p>
+            <a:pPr algn="ctr"/>
+          </a:p>
+        </p:txBody>
+      </p:sp>
+      <p:sp>
+        <p:nvSpPr>
+          <p:cNvPr id="37" name="TextBox 36"/>
+          <p:cNvSpPr txBox="1"/>
+          <p:nvPr/>
+        </p:nvSpPr>
+        <p:spPr>
+          <a:xfrm>
+            <a:off x="548640" y="4251960"/>
+            <a:ext cx="2743200" cy="365760"/>
+          </a:xfrm>
+          <a:prstGeom prst="rect">
+            <a:avLst/>
+          </a:prstGeom>
+          <a:noFill/>
+        </p:spPr>
+        <p:txBody>
+          <a:bodyPr wrap="square">
+            <a:spAutoFit/>
+          </a:bodyPr>
+          <a:lstStyle/>
+          <a:p>
+            <a:pPr algn="l">
+              <a:defRPr sz="1100" b="1">
+                <a:solidFill>
+                  <a:srgbClr val="1A1A1A"/>
+                </a:solidFill>
+                <a:latin typeface="Calibri"/>
+              </a:defRPr>
+            </a:pPr>
+            <a:r>
+              <a:t>Referensprojekt / Case studies</a:t>
+            </a:r>
+          </a:p>
+        </p:txBody>
+      </p:sp>
+      <p:sp>
+        <p:nvSpPr>
+          <p:cNvPr id="38" name="TextBox 37"/>
+          <p:cNvSpPr txBox="1"/>
+          <p:nvPr/>
+        </p:nvSpPr>
+        <p:spPr>
+          <a:xfrm>
+            <a:off x="3383280" y="4251960"/>
+            <a:ext cx="2286000" cy="365760"/>
+          </a:xfrm>
+          <a:prstGeom prst="rect">
+            <a:avLst/>
+          </a:prstGeom>
+          <a:noFill/>
+        </p:spPr>
+        <p:txBody>
+          <a:bodyPr wrap="square">
+            <a:spAutoFit/>
+          </a:bodyPr>
+          <a:lstStyle/>
+          <a:p>
+            <a:pPr algn="l">
+              <a:defRPr sz="900" b="0">
+                <a:solidFill>
+                  <a:srgbClr val="999999"/>
+                </a:solidFill>
+                <a:latin typeface="Calibri"/>
+              </a:defRPr>
+            </a:pPr>
+            <a:r>
+              <a:t>/referensprojekt/</a:t>
+            </a:r>
+          </a:p>
+        </p:txBody>
+      </p:sp>
+      <p:sp>
+        <p:nvSpPr>
+          <p:cNvPr id="39" name="TextBox 38"/>
+          <p:cNvSpPr txBox="1"/>
+          <p:nvPr/>
+        </p:nvSpPr>
+        <p:spPr>
+          <a:xfrm>
+            <a:off x="5669280" y="4251960"/>
+            <a:ext cx="1371600" cy="365760"/>
+          </a:xfrm>
+          <a:prstGeom prst="rect">
+            <a:avLst/>
+          </a:prstGeom>
+          <a:noFill/>
+        </p:spPr>
+        <p:txBody>
+          <a:bodyPr wrap="square">
+            <a:spAutoFit/>
+          </a:bodyPr>
+          <a:lstStyle/>
+          <a:p>
+            <a:pPr algn="l">
+              <a:defRPr sz="1100" b="1">
+                <a:solidFill>
+                  <a:srgbClr val="DD3333"/>
+                </a:solidFill>
+                <a:latin typeface="Calibri"/>
+              </a:defRPr>
+            </a:pPr>
+            <a:r>
+              <a:t>Trust-signal</a:t>
+            </a:r>
+          </a:p>
+        </p:txBody>
+      </p:sp>
+      <p:sp>
+        <p:nvSpPr>
+          <p:cNvPr id="40" name="TextBox 39"/>
+          <p:cNvSpPr txBox="1"/>
+          <p:nvPr/>
+        </p:nvSpPr>
+        <p:spPr>
+          <a:xfrm>
+            <a:off x="7040880" y="4251960"/>
+            <a:ext cx="1828800" cy="365760"/>
+          </a:xfrm>
+          <a:prstGeom prst="rect">
+            <a:avLst/>
+          </a:prstGeom>
+          <a:noFill/>
+        </p:spPr>
+        <p:txBody>
+          <a:bodyPr wrap="square">
+            <a:spAutoFit/>
+          </a:bodyPr>
+          <a:lstStyle/>
+          <a:p>
+            <a:pPr algn="l">
+              <a:defRPr sz="1000" b="0">
+                <a:solidFill>
+                  <a:srgbClr val="1A1A1A"/>
+                </a:solidFill>
+                <a:latin typeface="Calibri"/>
+              </a:defRPr>
+            </a:pPr>
+            <a:r>
+              <a:t>Konvertering, ej sökvolym</a:t>
+            </a:r>
+          </a:p>
+        </p:txBody>
+      </p:sp>
+      <p:sp>
+        <p:nvSpPr>
+          <p:cNvPr id="41" name="Rectangle 40"/>
+          <p:cNvSpPr/>
+          <p:nvPr/>
+        </p:nvSpPr>
+        <p:spPr>
+          <a:xfrm>
+            <a:off x="457200" y="4700016"/>
+            <a:ext cx="8229600" cy="438912"/>
+          </a:xfrm>
+          <a:prstGeom prst="rect">
+            <a:avLst/>
+          </a:prstGeom>
+          <a:solidFill>
+            <a:srgbClr val="F5F5F5"/>
+          </a:solidFill>
+          <a:ln>
+            <a:noFill/>
+          </a:ln>
+        </p:spPr>
+        <p:style>
+          <a:lnRef idx="1">
+            <a:schemeClr val="accent1"/>
+          </a:lnRef>
+          <a:fillRef idx="3">
+            <a:schemeClr val="accent1"/>
+          </a:fillRef>
+          <a:effectRef idx="2">
+            <a:schemeClr val="accent1"/>
+          </a:effectRef>
+          <a:fontRef idx="minor">
+            <a:schemeClr val="lt1"/>
+          </a:fontRef>
+        </p:style>
+        <p:txBody>
+          <a:bodyPr rtlCol="0" anchor="ctr"/>
+          <a:lstStyle/>
+          <a:p>
+            <a:pPr algn="ctr"/>
+          </a:p>
+        </p:txBody>
+      </p:sp>
+      <p:sp>
+        <p:nvSpPr>
+          <p:cNvPr id="42" name="TextBox 41"/>
+          <p:cNvSpPr txBox="1"/>
+          <p:nvPr/>
+        </p:nvSpPr>
+        <p:spPr>
+          <a:xfrm>
+            <a:off x="548640" y="4727448"/>
+            <a:ext cx="2743200" cy="365760"/>
+          </a:xfrm>
+          <a:prstGeom prst="rect">
+            <a:avLst/>
+          </a:prstGeom>
+          <a:noFill/>
+        </p:spPr>
+        <p:txBody>
+          <a:bodyPr wrap="square">
+            <a:spAutoFit/>
+          </a:bodyPr>
+          <a:lstStyle/>
+          <a:p>
+            <a:pPr algn="l">
+              <a:defRPr sz="1100" b="1">
+                <a:solidFill>
+                  <a:srgbClr val="1A1A1A"/>
+                </a:solidFill>
+                <a:latin typeface="Calibri"/>
+              </a:defRPr>
+            </a:pPr>
+            <a:r>
+              <a:t>Gjutteknisk ordlista</a:t>
+            </a:r>
+          </a:p>
+        </p:txBody>
+      </p:sp>
+      <p:sp>
+        <p:nvSpPr>
+          <p:cNvPr id="43" name="TextBox 42"/>
+          <p:cNvSpPr txBox="1"/>
+          <p:nvPr/>
+        </p:nvSpPr>
+        <p:spPr>
+          <a:xfrm>
+            <a:off x="3383280" y="4727448"/>
+            <a:ext cx="2286000" cy="365760"/>
+          </a:xfrm>
+          <a:prstGeom prst="rect">
+            <a:avLst/>
+          </a:prstGeom>
+          <a:noFill/>
+        </p:spPr>
+        <p:txBody>
+          <a:bodyPr wrap="square">
+            <a:spAutoFit/>
+          </a:bodyPr>
+          <a:lstStyle/>
+          <a:p>
+            <a:pPr algn="l">
+              <a:defRPr sz="900" b="0">
+                <a:solidFill>
+                  <a:srgbClr val="999999"/>
+                </a:solidFill>
+                <a:latin typeface="Calibri"/>
+              </a:defRPr>
+            </a:pPr>
+            <a:r>
+              <a:t>/ordlista/</a:t>
+            </a:r>
+          </a:p>
+        </p:txBody>
+      </p:sp>
+      <p:sp>
+        <p:nvSpPr>
+          <p:cNvPr id="44" name="TextBox 43"/>
+          <p:cNvSpPr txBox="1"/>
+          <p:nvPr/>
+        </p:nvSpPr>
+        <p:spPr>
+          <a:xfrm>
+            <a:off x="5669280" y="4727448"/>
+            <a:ext cx="1371600" cy="365760"/>
+          </a:xfrm>
+          <a:prstGeom prst="rect">
+            <a:avLst/>
+          </a:prstGeom>
+          <a:noFill/>
+        </p:spPr>
+        <p:txBody>
+          <a:bodyPr wrap="square">
+            <a:spAutoFit/>
+          </a:bodyPr>
+          <a:lstStyle/>
+          <a:p>
+            <a:pPr algn="l">
+              <a:defRPr sz="1100" b="1">
+                <a:solidFill>
+                  <a:srgbClr val="DD3333"/>
+                </a:solidFill>
+                <a:latin typeface="Calibri"/>
+              </a:defRPr>
+            </a:pPr>
+            <a:r>
+              <a:t>50+ longtail</a:t>
+            </a:r>
+          </a:p>
+        </p:txBody>
+      </p:sp>
+      <p:sp>
+        <p:nvSpPr>
+          <p:cNvPr id="45" name="TextBox 44"/>
+          <p:cNvSpPr txBox="1"/>
+          <p:nvPr/>
+        </p:nvSpPr>
+        <p:spPr>
+          <a:xfrm>
+            <a:off x="7040880" y="4727448"/>
+            <a:ext cx="1828800" cy="365760"/>
+          </a:xfrm>
+          <a:prstGeom prst="rect">
+            <a:avLst/>
+          </a:prstGeom>
+          <a:noFill/>
+        </p:spPr>
+        <p:txBody>
+          <a:bodyPr wrap="square">
+            <a:spAutoFit/>
+          </a:bodyPr>
+          <a:lstStyle/>
+          <a:p>
+            <a:pPr algn="l">
+              <a:defRPr sz="1000" b="0">
+                <a:solidFill>
+                  <a:srgbClr val="1A1A1A"/>
+                </a:solidFill>
+                <a:latin typeface="Calibri"/>
+              </a:defRPr>
+            </a:pPr>
+            <a:r>
+              <a:t>Featured snippets × 30</a:t>
+            </a:r>
+          </a:p>
+        </p:txBody>
+      </p:sp>
+      <p:sp>
+        <p:nvSpPr>
+          <p:cNvPr id="46" name="Rectangle 45"/>
+          <p:cNvSpPr/>
+          <p:nvPr/>
+        </p:nvSpPr>
+        <p:spPr>
+          <a:xfrm>
+            <a:off x="457200" y="5175503"/>
+            <a:ext cx="8229600" cy="438912"/>
+          </a:xfrm>
+          <a:prstGeom prst="rect">
+            <a:avLst/>
+          </a:prstGeom>
+          <a:solidFill>
+            <a:srgbClr val="FFFFFF"/>
+          </a:solidFill>
+          <a:ln>
+            <a:noFill/>
+          </a:ln>
+        </p:spPr>
+        <p:style>
+          <a:lnRef idx="1">
+            <a:schemeClr val="accent1"/>
+          </a:lnRef>
+          <a:fillRef idx="3">
+            <a:schemeClr val="accent1"/>
+          </a:fillRef>
+          <a:effectRef idx="2">
+            <a:schemeClr val="accent1"/>
+          </a:effectRef>
+          <a:fontRef idx="minor">
+            <a:schemeClr val="lt1"/>
+          </a:fontRef>
+        </p:style>
+        <p:txBody>
+          <a:bodyPr rtlCol="0" anchor="ctr"/>
+          <a:lstStyle/>
+          <a:p>
+            <a:pPr algn="ctr"/>
+          </a:p>
+        </p:txBody>
+      </p:sp>
+      <p:sp>
+        <p:nvSpPr>
+          <p:cNvPr id="47" name="TextBox 46"/>
+          <p:cNvSpPr txBox="1"/>
+          <p:nvPr/>
+        </p:nvSpPr>
+        <p:spPr>
+          <a:xfrm>
+            <a:off x="548640" y="5202936"/>
+            <a:ext cx="2743200" cy="365760"/>
+          </a:xfrm>
+          <a:prstGeom prst="rect">
+            <a:avLst/>
+          </a:prstGeom>
+          <a:noFill/>
+        </p:spPr>
+        <p:txBody>
+          <a:bodyPr wrap="square">
+            <a:spAutoFit/>
+          </a:bodyPr>
+          <a:lstStyle/>
+          <a:p>
+            <a:pPr algn="l">
+              <a:defRPr sz="1100" b="1">
+                <a:solidFill>
+                  <a:srgbClr val="1A1A1A"/>
+                </a:solidFill>
+                <a:latin typeface="Calibri"/>
+              </a:defRPr>
+            </a:pPr>
+            <a:r>
+              <a:t>Offert-sida med strukturerat formulär</a:t>
+            </a:r>
+          </a:p>
+        </p:txBody>
+      </p:sp>
+      <p:sp>
+        <p:nvSpPr>
+          <p:cNvPr id="48" name="TextBox 47"/>
+          <p:cNvSpPr txBox="1"/>
+          <p:nvPr/>
+        </p:nvSpPr>
+        <p:spPr>
+          <a:xfrm>
+            <a:off x="3383280" y="5202936"/>
+            <a:ext cx="2286000" cy="365760"/>
+          </a:xfrm>
+          <a:prstGeom prst="rect">
+            <a:avLst/>
+          </a:prstGeom>
+          <a:noFill/>
+        </p:spPr>
+        <p:txBody>
+          <a:bodyPr wrap="square">
+            <a:spAutoFit/>
+          </a:bodyPr>
+          <a:lstStyle/>
+          <a:p>
+            <a:pPr algn="l">
+              <a:defRPr sz="900" b="0">
+                <a:solidFill>
+                  <a:srgbClr val="999999"/>
+                </a:solidFill>
+                <a:latin typeface="Calibri"/>
+              </a:defRPr>
+            </a:pPr>
+            <a:r>
+              <a:t>/offert/</a:t>
+            </a:r>
+          </a:p>
+        </p:txBody>
+      </p:sp>
+      <p:sp>
+        <p:nvSpPr>
+          <p:cNvPr id="49" name="TextBox 48"/>
+          <p:cNvSpPr txBox="1"/>
+          <p:nvPr/>
+        </p:nvSpPr>
+        <p:spPr>
+          <a:xfrm>
+            <a:off x="5669280" y="5202936"/>
+            <a:ext cx="1371600" cy="365760"/>
+          </a:xfrm>
+          <a:prstGeom prst="rect">
+            <a:avLst/>
+          </a:prstGeom>
+          <a:noFill/>
+        </p:spPr>
+        <p:txBody>
+          <a:bodyPr wrap="square">
+            <a:spAutoFit/>
+          </a:bodyPr>
+          <a:lstStyle/>
+          <a:p>
+            <a:pPr algn="l">
+              <a:defRPr sz="1100" b="1">
+                <a:solidFill>
+                  <a:srgbClr val="DD3333"/>
+                </a:solidFill>
+                <a:latin typeface="Calibri"/>
+              </a:defRPr>
+            </a:pPr>
+            <a:r>
+              <a:t>Konvertering</a:t>
+            </a:r>
+          </a:p>
+        </p:txBody>
+      </p:sp>
+      <p:sp>
+        <p:nvSpPr>
+          <p:cNvPr id="50" name="TextBox 49"/>
+          <p:cNvSpPr txBox="1"/>
+          <p:nvPr/>
+        </p:nvSpPr>
+        <p:spPr>
+          <a:xfrm>
+            <a:off x="7040880" y="5202936"/>
+            <a:ext cx="1828800" cy="365760"/>
+          </a:xfrm>
+          <a:prstGeom prst="rect">
+            <a:avLst/>
+          </a:prstGeom>
+          <a:noFill/>
+        </p:spPr>
+        <p:txBody>
+          <a:bodyPr wrap="square">
+            <a:spAutoFit/>
+          </a:bodyPr>
+          <a:lstStyle/>
+          <a:p>
+            <a:pPr algn="l">
+              <a:defRPr sz="1000" b="0">
+                <a:solidFill>
+                  <a:srgbClr val="1A1A1A"/>
+                </a:solidFill>
+                <a:latin typeface="Calibri"/>
+              </a:defRPr>
+            </a:pPr>
+            <a:r>
+              <a:t>Material, volym, tolerans, deadline</a:t>
+            </a:r>
+          </a:p>
+        </p:txBody>
+      </p:sp>
+      <p:sp>
+        <p:nvSpPr>
+          <p:cNvPr id="51" name="TextBox 50"/>
+          <p:cNvSpPr txBox="1"/>
+          <p:nvPr/>
+        </p:nvSpPr>
+        <p:spPr>
+          <a:xfrm>
+            <a:off x="457200" y="5760720"/>
+            <a:ext cx="8229600" cy="365760"/>
+          </a:xfrm>
+          <a:prstGeom prst="rect">
+            <a:avLst/>
+          </a:prstGeom>
+          <a:noFill/>
+        </p:spPr>
+        <p:txBody>
+          <a:bodyPr wrap="square">
+            <a:spAutoFit/>
+          </a:bodyPr>
+          <a:lstStyle/>
+          <a:p>
+            <a:pPr algn="l">
+              <a:defRPr sz="1100" b="0">
+                <a:solidFill>
+                  <a:srgbClr val="999999"/>
+                </a:solidFill>
+                <a:latin typeface="Calibri"/>
+              </a:defRPr>
+            </a:pPr>
+            <a:r>
+              <a:t>Alla sidor byggs SEO-first med internlänkar till befintliga artiklar och tjänstesidor — multiplicerar effekten av allt vi redan gjort.</a:t>
+            </a:r>
           </a:p>
         </p:txBody>
       </p:sp>

</xml_diff>